<commit_message>
chore: gitignore PROGRESS.md + 更新用户指南/技术设计 PPT
- .gitignore: 新增 PROGRESS.md 规则（运行时进度文件不入库）
- flow-kit-用户指南.pptx: Slide 5 + /flow model 命令, Slide 16 + correction 类型收割
- flow-kit-技术设计.pptx: Slide 15 + correction 收割策略

Co-Authored-By: Claude <noreply@anthropic.com>
</commit_message>
<xml_diff>
--- a/flow-kit-用户指南.pptx
+++ b/flow-kit-用户指南.pptx
@@ -18,6 +18,7 @@
     <p:sldId id="266" r:id="rId17"/>
     <p:sldId id="267" r:id="rId18"/>
     <p:sldId id="268" r:id="rId19"/>
+    <p:sldId id="274" r:id="rId25"/>
     <p:sldId id="269" r:id="rId20"/>
     <p:sldId id="270" r:id="rId21"/>
     <p:sldId id="271" r:id="rId22"/>
@@ -3256,7 +3257,7 @@
                 <a:latin typeface="Times New Roman"/>
                 <a:ea typeface="宋体"/>
               </a:rPr>
-              <a:t>2026-07-13  |  github.com/hellrabb/flow-kit</a:t>
+              <a:t>2026-07-24  |  github.com/hellrabb/flow-kit</a:t>
             </a:r>
           </a:p>
         </p:txBody>
@@ -4987,18 +4988,19 @@
         </p:nvSpPr>
         <p:spPr>
           <a:xfrm>
-            <a:off x="731520" y="320040"/>
-            <a:ext cx="54864" cy="365760"/>
+            <a:off x="-45720" y="-45720"/>
+            <a:ext cx="12283135" cy="6949440"/>
           </a:xfrm>
           <a:prstGeom prst="rect">
             <a:avLst/>
           </a:prstGeom>
           <a:solidFill>
-            <a:srgbClr val="2563EB"/>
+            <a:srgbClr val="FFFFFF"/>
           </a:solidFill>
           <a:ln>
             <a:noFill/>
           </a:ln>
+          <a:effectLst/>
         </p:spPr>
         <p:style>
           <a:lnRef idx="1">
@@ -5024,61 +5026,25 @@
       </p:sp>
       <p:sp>
         <p:nvSpPr>
-          <p:cNvPr id="3" name="TextBox 2"/>
-          <p:cNvSpPr txBox="1"/>
-          <p:nvPr/>
-        </p:nvSpPr>
-        <p:spPr>
-          <a:xfrm>
-            <a:off x="914400" y="274320"/>
-            <a:ext cx="10515600" cy="502920"/>
-          </a:xfrm>
-          <a:prstGeom prst="rect">
-            <a:avLst/>
-          </a:prstGeom>
-          <a:noFill/>
-        </p:spPr>
-        <p:txBody>
-          <a:bodyPr wrap="square">
-            <a:spAutoFit/>
-          </a:bodyPr>
-          <a:lstStyle/>
-          <a:p>
-            <a:r>
-              <a:rPr sz="2400" b="1" i="0">
-                <a:solidFill>
-                  <a:srgbClr val="1E293B"/>
-                </a:solidFill>
-                <a:latin typeface="Times New Roman"/>
-                <a:ea typeface="宋体"/>
-              </a:rPr>
-              <a:t>横向命令（独立于流水线）</a:t>
-            </a:r>
-          </a:p>
-        </p:txBody>
-      </p:sp>
-      <p:sp>
-        <p:nvSpPr>
-          <p:cNvPr id="4" name="Rectangle 3"/>
+          <p:cNvPr id="3" name="Rectangle 2"/>
           <p:cNvSpPr/>
           <p:nvPr/>
         </p:nvSpPr>
         <p:spPr>
           <a:xfrm>
-            <a:off x="731520" y="1234440"/>
-            <a:ext cx="3291840" cy="2103120"/>
+            <a:off x="0" y="0"/>
+            <a:ext cx="12191695" cy="1051560"/>
           </a:xfrm>
           <a:prstGeom prst="rect">
             <a:avLst/>
           </a:prstGeom>
           <a:solidFill>
-            <a:srgbClr val="FFFFFF"/>
+            <a:srgbClr val="1F3A5F"/>
           </a:solidFill>
-          <a:ln w="12700">
-            <a:solidFill>
-              <a:srgbClr val="E2E8F0"/>
-            </a:solidFill>
+          <a:ln>
+            <a:noFill/>
           </a:ln>
+          <a:effectLst/>
         </p:spPr>
         <p:style>
           <a:lnRef idx="1">
@@ -5104,14 +5070,73 @@
       </p:sp>
       <p:sp>
         <p:nvSpPr>
+          <p:cNvPr id="4" name="TextBox 3"/>
+          <p:cNvSpPr txBox="1"/>
+          <p:nvPr/>
+        </p:nvSpPr>
+        <p:spPr>
+          <a:xfrm>
+            <a:off x="457200" y="137160"/>
+            <a:ext cx="11277295" cy="822960"/>
+          </a:xfrm>
+          <a:prstGeom prst="rect">
+            <a:avLst/>
+          </a:prstGeom>
+          <a:noFill/>
+        </p:spPr>
+        <p:txBody>
+          <a:bodyPr wrap="square" anchor="ctr">
+            <a:spAutoFit/>
+          </a:bodyPr>
+          <a:lstStyle/>
+          <a:p>
+            <a:pPr>
+              <a:spcAft>
+                <a:spcPts val="400"/>
+              </a:spcAft>
+            </a:pPr>
+            <a:r>
+              <a:rPr sz="2600" b="1">
+                <a:solidFill>
+                  <a:srgbClr val="FFFFFF"/>
+                </a:solidFill>
+                <a:latin typeface="Times New Roman"/>
+                <a:ea typeface="宋体"/>
+                <a:cs typeface="宋体"/>
+              </a:rPr>
+              <a:t>L2/L3 模型配置三级优先级链</a:t>
+            </a:r>
+          </a:p>
+          <a:p>
+            <a:pPr>
+              <a:spcAft>
+                <a:spcPts val="400"/>
+              </a:spcAft>
+            </a:pPr>
+            <a:r>
+              <a:rPr sz="1200" b="0">
+                <a:solidFill>
+                  <a:srgbClr val="A8C4E0"/>
+                </a:solidFill>
+                <a:latin typeface="Times New Roman"/>
+                <a:ea typeface="宋体"/>
+                <a:cs typeface="宋体"/>
+              </a:rPr>
+              <a:t>ADR-012 / ADR-013 · fk_resolve_model · 2026-07-24</a:t>
+            </a:r>
+          </a:p>
+        </p:txBody>
+      </p:sp>
+      <p:sp>
+        <p:nvSpPr>
           <p:cNvPr id="5" name="TextBox 4"/>
           <p:cNvSpPr txBox="1"/>
           <p:nvPr/>
         </p:nvSpPr>
         <p:spPr>
           <a:xfrm>
-            <a:off x="914400" y="1371600"/>
-            <a:ext cx="2926080" cy="365760"/>
+            <a:off x="548640" y="1280160"/>
+            <a:ext cx="11094415" cy="5212080"/>
           </a:xfrm>
           <a:prstGeom prst="rect">
             <a:avLst/>
@@ -5124,525 +5149,147 @@
           </a:bodyPr>
           <a:lstStyle/>
           <a:p>
-            <a:r>
-              <a:rPr sz="1400" b="1" i="0">
-                <a:solidFill>
-                  <a:srgbClr val="2563EB"/>
-                </a:solidFill>
-                <a:latin typeface="Times New Roman"/>
-                <a:ea typeface="宋体"/>
-              </a:rPr>
-              <a:t>I-intel · 入场扫描</a:t>
-            </a:r>
-          </a:p>
-        </p:txBody>
-      </p:sp>
-      <p:sp>
-        <p:nvSpPr>
-          <p:cNvPr id="6" name="TextBox 5"/>
-          <p:cNvSpPr txBox="1"/>
-          <p:nvPr/>
-        </p:nvSpPr>
-        <p:spPr>
-          <a:xfrm>
-            <a:off x="914400" y="1783080"/>
-            <a:ext cx="2926080" cy="1371600"/>
-          </a:xfrm>
-          <a:prstGeom prst="rect">
-            <a:avLst/>
-          </a:prstGeom>
-          <a:noFill/>
-        </p:spPr>
-        <p:txBody>
-          <a:bodyPr wrap="square">
-            <a:spAutoFit/>
-          </a:bodyPr>
-          <a:lstStyle/>
-          <a:p>
-            <a:r>
-              <a:rPr sz="1000" b="0" i="0">
-                <a:solidFill>
-                  <a:srgbClr val="475569"/>
-                </a:solidFill>
-                <a:latin typeface="Times New Roman"/>
-                <a:ea typeface="宋体"/>
-              </a:rPr>
-              <a:t>生成 CONTEXT.md
-术语表 + 既有抽象索引
-+ 禁动清单 + 命名约定
-首次使用 flow-kit 必跑</a:t>
-            </a:r>
-          </a:p>
-        </p:txBody>
-      </p:sp>
-      <p:sp>
-        <p:nvSpPr>
-          <p:cNvPr id="7" name="Rectangle 6"/>
-          <p:cNvSpPr/>
-          <p:nvPr/>
-        </p:nvSpPr>
-        <p:spPr>
-          <a:xfrm>
-            <a:off x="4251960" y="1234440"/>
-            <a:ext cx="3291840" cy="2103120"/>
-          </a:xfrm>
-          <a:prstGeom prst="rect">
-            <a:avLst/>
-          </a:prstGeom>
-          <a:solidFill>
-            <a:srgbClr val="FFFFFF"/>
-          </a:solidFill>
-          <a:ln w="12700">
-            <a:solidFill>
-              <a:srgbClr val="E2E8F0"/>
-            </a:solidFill>
-          </a:ln>
-        </p:spPr>
-        <p:style>
-          <a:lnRef idx="1">
-            <a:schemeClr val="accent1"/>
-          </a:lnRef>
-          <a:fillRef idx="3">
-            <a:schemeClr val="accent1"/>
-          </a:fillRef>
-          <a:effectRef idx="2">
-            <a:schemeClr val="accent1"/>
-          </a:effectRef>
-          <a:fontRef idx="minor">
-            <a:schemeClr val="lt1"/>
-          </a:fontRef>
-        </p:style>
-        <p:txBody>
-          <a:bodyPr rtlCol="0" anchor="ctr"/>
-          <a:lstStyle/>
-          <a:p>
-            <a:pPr algn="ctr"/>
-          </a:p>
-        </p:txBody>
-      </p:sp>
-      <p:sp>
-        <p:nvSpPr>
-          <p:cNvPr id="8" name="TextBox 7"/>
-          <p:cNvSpPr txBox="1"/>
-          <p:nvPr/>
-        </p:nvSpPr>
-        <p:spPr>
-          <a:xfrm>
-            <a:off x="4434840" y="1371600"/>
-            <a:ext cx="2926080" cy="365760"/>
-          </a:xfrm>
-          <a:prstGeom prst="rect">
-            <a:avLst/>
-          </a:prstGeom>
-          <a:noFill/>
-        </p:spPr>
-        <p:txBody>
-          <a:bodyPr wrap="square">
-            <a:spAutoFit/>
-          </a:bodyPr>
-          <a:lstStyle/>
-          <a:p>
-            <a:r>
-              <a:rPr sz="1400" b="1" i="0">
-                <a:solidFill>
-                  <a:srgbClr val="2563EB"/>
-                </a:solidFill>
-                <a:latin typeface="Times New Roman"/>
-                <a:ea typeface="宋体"/>
-              </a:rPr>
-              <a:t>M-health · 健康巡检</a:t>
-            </a:r>
-          </a:p>
-        </p:txBody>
-      </p:sp>
-      <p:sp>
-        <p:nvSpPr>
-          <p:cNvPr id="9" name="TextBox 8"/>
-          <p:cNvSpPr txBox="1"/>
-          <p:nvPr/>
-        </p:nvSpPr>
-        <p:spPr>
-          <a:xfrm>
-            <a:off x="4434840" y="1783080"/>
-            <a:ext cx="2926080" cy="1371600"/>
-          </a:xfrm>
-          <a:prstGeom prst="rect">
-            <a:avLst/>
-          </a:prstGeom>
-          <a:noFill/>
-        </p:spPr>
-        <p:txBody>
-          <a:bodyPr wrap="square">
-            <a:spAutoFit/>
-          </a:bodyPr>
-          <a:lstStyle/>
-          <a:p>
-            <a:r>
-              <a:rPr sz="1000" b="0" i="0">
-                <a:solidFill>
-                  <a:srgbClr val="475569"/>
-                </a:solidFill>
-                <a:latin typeface="Times New Roman"/>
-                <a:ea typeface="宋体"/>
-              </a:rPr>
-              <a:t>代码库健康诊断 + 技术债盘点
-快速/标准/深度三种模式
-brooks-lint 优先，AI 内置回退
-冗余扫描：jscpd/knip/depcheck</a:t>
-            </a:r>
-          </a:p>
-        </p:txBody>
-      </p:sp>
-      <p:sp>
-        <p:nvSpPr>
-          <p:cNvPr id="10" name="Rectangle 9"/>
-          <p:cNvSpPr/>
-          <p:nvPr/>
-        </p:nvSpPr>
-        <p:spPr>
-          <a:xfrm>
-            <a:off x="7772400" y="1234440"/>
-            <a:ext cx="3291840" cy="2103120"/>
-          </a:xfrm>
-          <a:prstGeom prst="rect">
-            <a:avLst/>
-          </a:prstGeom>
-          <a:solidFill>
-            <a:srgbClr val="FFFFFF"/>
-          </a:solidFill>
-          <a:ln w="12700">
-            <a:solidFill>
-              <a:srgbClr val="E2E8F0"/>
-            </a:solidFill>
-          </a:ln>
-        </p:spPr>
-        <p:style>
-          <a:lnRef idx="1">
-            <a:schemeClr val="accent1"/>
-          </a:lnRef>
-          <a:fillRef idx="3">
-            <a:schemeClr val="accent1"/>
-          </a:fillRef>
-          <a:effectRef idx="2">
-            <a:schemeClr val="accent1"/>
-          </a:effectRef>
-          <a:fontRef idx="minor">
-            <a:schemeClr val="lt1"/>
-          </a:fontRef>
-        </p:style>
-        <p:txBody>
-          <a:bodyPr rtlCol="0" anchor="ctr"/>
-          <a:lstStyle/>
-          <a:p>
-            <a:pPr algn="ctr"/>
-          </a:p>
-        </p:txBody>
-      </p:sp>
-      <p:sp>
-        <p:nvSpPr>
-          <p:cNvPr id="11" name="TextBox 10"/>
-          <p:cNvSpPr txBox="1"/>
-          <p:nvPr/>
-        </p:nvSpPr>
-        <p:spPr>
-          <a:xfrm>
-            <a:off x="7955280" y="1371600"/>
-            <a:ext cx="2926080" cy="365760"/>
-          </a:xfrm>
-          <a:prstGeom prst="rect">
-            <a:avLst/>
-          </a:prstGeom>
-          <a:noFill/>
-        </p:spPr>
-        <p:txBody>
-          <a:bodyPr wrap="square">
-            <a:spAutoFit/>
-          </a:bodyPr>
-          <a:lstStyle/>
-          <a:p>
-            <a:r>
-              <a:rPr sz="1400" b="1" i="0">
-                <a:solidFill>
-                  <a:srgbClr val="2563EB"/>
-                </a:solidFill>
-                <a:latin typeface="Times New Roman"/>
-                <a:ea typeface="宋体"/>
-              </a:rPr>
-              <a:t>A-architect · 架构文档</a:t>
-            </a:r>
-          </a:p>
-        </p:txBody>
-      </p:sp>
-      <p:sp>
-        <p:nvSpPr>
-          <p:cNvPr id="12" name="TextBox 11"/>
-          <p:cNvSpPr txBox="1"/>
-          <p:nvPr/>
-        </p:nvSpPr>
-        <p:spPr>
-          <a:xfrm>
-            <a:off x="7955280" y="1783080"/>
-            <a:ext cx="2926080" cy="1371600"/>
-          </a:xfrm>
-          <a:prstGeom prst="rect">
-            <a:avLst/>
-          </a:prstGeom>
-          <a:noFill/>
-        </p:spPr>
-        <p:txBody>
-          <a:bodyPr wrap="square">
-            <a:spAutoFit/>
-          </a:bodyPr>
-          <a:lstStyle/>
-          <a:p>
-            <a:r>
-              <a:rPr sz="1000" b="0" i="0">
-                <a:solidFill>
-                  <a:srgbClr val="475569"/>
-                </a:solidFill>
-                <a:latin typeface="Times New Roman"/>
-                <a:ea typeface="宋体"/>
-              </a:rPr>
-              <a:t>生成 ARCHITECTURE.md + ADR
-系统概览 + 模块清单
-+ 跨模块契约 + 容量边界
-首次/重构时建立</a:t>
-            </a:r>
-          </a:p>
-        </p:txBody>
-      </p:sp>
-      <p:sp>
-        <p:nvSpPr>
-          <p:cNvPr id="13" name="Rectangle 12"/>
-          <p:cNvSpPr/>
-          <p:nvPr/>
-        </p:nvSpPr>
-        <p:spPr>
-          <a:xfrm>
-            <a:off x="731520" y="3566160"/>
-            <a:ext cx="3291840" cy="2103120"/>
-          </a:xfrm>
-          <a:prstGeom prst="rect">
-            <a:avLst/>
-          </a:prstGeom>
-          <a:solidFill>
-            <a:srgbClr val="FFFFFF"/>
-          </a:solidFill>
-          <a:ln w="12700">
-            <a:solidFill>
-              <a:srgbClr val="E2E8F0"/>
-            </a:solidFill>
-          </a:ln>
-        </p:spPr>
-        <p:style>
-          <a:lnRef idx="1">
-            <a:schemeClr val="accent1"/>
-          </a:lnRef>
-          <a:fillRef idx="3">
-            <a:schemeClr val="accent1"/>
-          </a:fillRef>
-          <a:effectRef idx="2">
-            <a:schemeClr val="accent1"/>
-          </a:effectRef>
-          <a:fontRef idx="minor">
-            <a:schemeClr val="lt1"/>
-          </a:fontRef>
-        </p:style>
-        <p:txBody>
-          <a:bodyPr rtlCol="0" anchor="ctr"/>
-          <a:lstStyle/>
-          <a:p>
-            <a:pPr algn="ctr"/>
-          </a:p>
-        </p:txBody>
-      </p:sp>
-      <p:sp>
-        <p:nvSpPr>
-          <p:cNvPr id="14" name="TextBox 13"/>
-          <p:cNvSpPr txBox="1"/>
-          <p:nvPr/>
-        </p:nvSpPr>
-        <p:spPr>
-          <a:xfrm>
-            <a:off x="914400" y="3703320"/>
-            <a:ext cx="2926080" cy="365760"/>
-          </a:xfrm>
-          <a:prstGeom prst="rect">
-            <a:avLst/>
-          </a:prstGeom>
-          <a:noFill/>
-        </p:spPr>
-        <p:txBody>
-          <a:bodyPr wrap="square">
-            <a:spAutoFit/>
-          </a:bodyPr>
-          <a:lstStyle/>
-          <a:p>
-            <a:r>
-              <a:rPr sz="1400" b="1" i="0">
-                <a:solidFill>
-                  <a:srgbClr val="2563EB"/>
-                </a:solidFill>
-                <a:latin typeface="Times New Roman"/>
-                <a:ea typeface="宋体"/>
-              </a:rPr>
-              <a:t>A-evolve · 架构沉淀</a:t>
-            </a:r>
-          </a:p>
-        </p:txBody>
-      </p:sp>
-      <p:sp>
-        <p:nvSpPr>
-          <p:cNvPr id="15" name="TextBox 14"/>
-          <p:cNvSpPr txBox="1"/>
-          <p:nvPr/>
-        </p:nvSpPr>
-        <p:spPr>
-          <a:xfrm>
-            <a:off x="914400" y="4114800"/>
-            <a:ext cx="2926080" cy="1371600"/>
-          </a:xfrm>
-          <a:prstGeom prst="rect">
-            <a:avLst/>
-          </a:prstGeom>
-          <a:noFill/>
-        </p:spPr>
-        <p:txBody>
-          <a:bodyPr wrap="square">
-            <a:spAutoFit/>
-          </a:bodyPr>
-          <a:lstStyle/>
-          <a:p>
-            <a:r>
-              <a:rPr sz="1000" b="0" i="0">
-                <a:solidFill>
-                  <a:srgbClr val="475569"/>
-                </a:solidFill>
-                <a:latin typeface="Times New Roman"/>
-                <a:ea typeface="宋体"/>
-              </a:rPr>
-              <a:t>扫描已归档 DESIGN.md §9
-聚合分类 → 用户 review
-→ patch CONTEXT.md
-+ ARCHITECTURE.md</a:t>
-            </a:r>
-          </a:p>
-        </p:txBody>
-      </p:sp>
-      <p:sp>
-        <p:nvSpPr>
-          <p:cNvPr id="16" name="Rectangle 15"/>
-          <p:cNvSpPr/>
-          <p:nvPr/>
-        </p:nvSpPr>
-        <p:spPr>
-          <a:xfrm>
-            <a:off x="4251960" y="3566160"/>
-            <a:ext cx="3291840" cy="2103120"/>
-          </a:xfrm>
-          <a:prstGeom prst="rect">
-            <a:avLst/>
-          </a:prstGeom>
-          <a:solidFill>
-            <a:srgbClr val="FFFFFF"/>
-          </a:solidFill>
-          <a:ln w="12700">
-            <a:solidFill>
-              <a:srgbClr val="E2E8F0"/>
-            </a:solidFill>
-          </a:ln>
-        </p:spPr>
-        <p:style>
-          <a:lnRef idx="1">
-            <a:schemeClr val="accent1"/>
-          </a:lnRef>
-          <a:fillRef idx="3">
-            <a:schemeClr val="accent1"/>
-          </a:fillRef>
-          <a:effectRef idx="2">
-            <a:schemeClr val="accent1"/>
-          </a:effectRef>
-          <a:fontRef idx="minor">
-            <a:schemeClr val="lt1"/>
-          </a:fontRef>
-        </p:style>
-        <p:txBody>
-          <a:bodyPr rtlCol="0" anchor="ctr"/>
-          <a:lstStyle/>
-          <a:p>
-            <a:pPr algn="ctr"/>
-          </a:p>
-        </p:txBody>
-      </p:sp>
-      <p:sp>
-        <p:nvSpPr>
-          <p:cNvPr id="17" name="TextBox 16"/>
-          <p:cNvSpPr txBox="1"/>
-          <p:nvPr/>
-        </p:nvSpPr>
-        <p:spPr>
-          <a:xfrm>
-            <a:off x="4434840" y="3703320"/>
-            <a:ext cx="2926080" cy="365760"/>
-          </a:xfrm>
-          <a:prstGeom prst="rect">
-            <a:avLst/>
-          </a:prstGeom>
-          <a:noFill/>
-        </p:spPr>
-        <p:txBody>
-          <a:bodyPr wrap="square">
-            <a:spAutoFit/>
-          </a:bodyPr>
-          <a:lstStyle/>
-          <a:p>
-            <a:r>
-              <a:rPr sz="1400" b="1" i="0">
-                <a:solidFill>
-                  <a:srgbClr val="2563EB"/>
-                </a:solidFill>
-                <a:latin typeface="Times New Roman"/>
-                <a:ea typeface="宋体"/>
-              </a:rPr>
-              <a:t>L-restyle · 视觉重构</a:t>
-            </a:r>
-          </a:p>
-        </p:txBody>
-      </p:sp>
-      <p:sp>
-        <p:nvSpPr>
-          <p:cNvPr id="18" name="TextBox 17"/>
-          <p:cNvSpPr txBox="1"/>
-          <p:nvPr/>
-        </p:nvSpPr>
-        <p:spPr>
-          <a:xfrm>
-            <a:off x="4434840" y="4114800"/>
-            <a:ext cx="2926080" cy="1371600"/>
-          </a:xfrm>
-          <a:prstGeom prst="rect">
-            <a:avLst/>
-          </a:prstGeom>
-          <a:noFill/>
-        </p:spPr>
-        <p:txBody>
-          <a:bodyPr wrap="square">
-            <a:spAutoFit/>
-          </a:bodyPr>
-          <a:lstStyle/>
-          <a:p>
-            <a:r>
-              <a:rPr sz="1000" b="0" i="0">
-                <a:solidFill>
-                  <a:srgbClr val="475569"/>
-                </a:solidFill>
-                <a:latin typeface="Times New Roman"/>
-                <a:ea typeface="宋体"/>
-              </a:rPr>
-              <a:t>保留功能，重做 UI 视觉
-自动生成 change-id
-v1→v2 视觉对照表
-组件库迁移/品牌升级适用</a:t>
+            <a:pPr>
+              <a:spcAft>
+                <a:spcPts val="800"/>
+              </a:spcAft>
+            </a:pPr>
+            <a:r>
+              <a:rPr sz="1500" b="0">
+                <a:solidFill>
+                  <a:srgbClr val="1F3A5F"/>
+                </a:solidFill>
+                <a:latin typeface="Times New Roman"/>
+                <a:ea typeface="宋体"/>
+                <a:cs typeface="宋体"/>
+              </a:rPr>
+              <a:t>公共函数 fk_resolve_model &lt;layer&gt;（hooks/stop/lib/common.sh）按三级优先级链解析——每级取非空值即停，全空优雅降级（不崩溃、不阻塞 session）。</a:t>
+            </a:r>
+          </a:p>
+          <a:p>
+            <a:pPr lvl="1">
+              <a:spcAft>
+                <a:spcPts val="300"/>
+              </a:spcAft>
+            </a:pPr>
+            <a:r>
+              <a:rPr sz="1300" b="0">
+                <a:solidFill>
+                  <a:srgbClr val="2E86AB"/>
+                </a:solidFill>
+                <a:latin typeface="Times New Roman"/>
+                <a:ea typeface="宋体"/>
+                <a:cs typeface="宋体"/>
+              </a:rPr>
+              <a:t>优先级 1 · ANTHROPIC_DEFAULT_HAIKU_MODEL (L3) / ANTHROPIC_L2_MODEL (L2) — CC 原生 env，CC 用户优先命中</a:t>
+            </a:r>
+          </a:p>
+          <a:p>
+            <a:pPr lvl="1">
+              <a:spcAft>
+                <a:spcPts val="300"/>
+              </a:spcAft>
+            </a:pPr>
+            <a:r>
+              <a:rPr sz="1300" b="0">
+                <a:solidFill>
+                  <a:srgbClr val="2E86AB"/>
+                </a:solidFill>
+                <a:latin typeface="Times New Roman"/>
+                <a:ea typeface="宋体"/>
+                <a:cs typeface="宋体"/>
+              </a:rPr>
+              <a:t>优先级 2 · FLOW_KIT_L3_MODEL / FLOW_KIT_L2_MODEL — 新增，临时覆盖（export 即生效）</a:t>
+            </a:r>
+          </a:p>
+          <a:p>
+            <a:pPr lvl="1">
+              <a:spcAft>
+                <a:spcPts val="300"/>
+              </a:spcAft>
+            </a:pPr>
+            <a:r>
+              <a:rPr sz="1300" b="0">
+                <a:solidFill>
+                  <a:srgbClr val="2E86AB"/>
+                </a:solidFill>
+                <a:latin typeface="Times New Roman"/>
+                <a:ea typeface="宋体"/>
+                <a:cs typeface="宋体"/>
+              </a:rPr>
+              <a:t>优先级 3 · .flow-active.goal.l3_model / l2_model — 持久化，由 /flow model l*=&lt;模型&gt; 写入</a:t>
+            </a:r>
+          </a:p>
+          <a:p>
+            <a:pPr lvl="1">
+              <a:spcAft>
+                <a:spcPts val="800"/>
+              </a:spcAft>
+            </a:pPr>
+            <a:r>
+              <a:rPr sz="1300" b="0">
+                <a:solidFill>
+                  <a:srgbClr val="C7463B"/>
+                </a:solidFill>
+                <a:latin typeface="Times New Roman"/>
+                <a:ea typeface="宋体"/>
+                <a:cs typeface="宋体"/>
+              </a:rPr>
+              <a:t>全空 → 优雅降级：写 .flow-active.correction（l3/l2-model-missing）+ stderr 提示，29 顶层 exit 3 不阻塞 gate 链</a:t>
+            </a:r>
+          </a:p>
+          <a:p>
+            <a:pPr>
+              <a:spcAft>
+                <a:spcPts val="400"/>
+              </a:spcAft>
+            </a:pPr>
+            <a:r>
+              <a:rPr sz="1300" b="0">
+                <a:solidFill>
+                  <a:srgbClr val="1F3A5F"/>
+                </a:solidFill>
+                <a:latin typeface="Times New Roman"/>
+                <a:ea typeface="宋体"/>
+                <a:cs typeface="宋体"/>
+              </a:rPr>
+              <a:t>ADR-013 覆盖写策略：compliance &gt; model-missing — 当前 correction 若为 compliance 且 violations 非空则不覆盖（保安全信息）；否则覆盖为 model-missing。</a:t>
+            </a:r>
+          </a:p>
+          <a:p>
+            <a:pPr>
+              <a:spcAft>
+                <a:spcPts val="400"/>
+              </a:spcAft>
+            </a:pPr>
+            <a:r>
+              <a:rPr sz="1300" b="0">
+                <a:solidFill>
+                  <a:srgbClr val="6C757D"/>
+                </a:solidFill>
+                <a:latin typeface="Times New Roman"/>
+                <a:ea typeface="宋体"/>
+                <a:cs typeface="宋体"/>
+              </a:rPr>
+              <a:t>SessionStart 收割：flow-kit-resume.sh 按 type 分类型——compliance/未知删；l3/l2-model-missing 持续提示（由 write_model_missing_clear 退场）。</a:t>
+            </a:r>
+          </a:p>
+          <a:p>
+            <a:pPr>
+              <a:spcAft>
+                <a:spcPts val="400"/>
+              </a:spcAft>
+            </a:pPr>
+            <a:r>
+              <a:rPr sz="1200" b="0">
+                <a:solidFill>
+                  <a:srgbClr val="6C757D"/>
+                </a:solidFill>
+                <a:latin typeface="Times New Roman"/>
+                <a:ea typeface="宋体"/>
+                <a:cs typeface="宋体"/>
+              </a:rPr>
+              <a:t>L2 已移除 claude-sonnet-5 fallback（纯跨平台）；未设 env 的 CC 用户升级后 L2 将降级，CHANGELOG 标注。</a:t>
             </a:r>
           </a:p>
         </p:txBody>
@@ -5738,21 +5385,66 @@
                 <a:latin typeface="Times New Roman"/>
                 <a:ea typeface="宋体"/>
               </a:rPr>
-              <a:t>Stop Hook 系统（17 模块）</a:t>
-            </a:r>
-          </a:p>
-        </p:txBody>
-      </p:sp>
-      <p:sp>
-        <p:nvSpPr>
-          <p:cNvPr id="4" name="TextBox 3"/>
+              <a:t>横向命令（独立于流水线）</a:t>
+            </a:r>
+          </a:p>
+        </p:txBody>
+      </p:sp>
+      <p:sp>
+        <p:nvSpPr>
+          <p:cNvPr id="4" name="Rectangle 3"/>
+          <p:cNvSpPr/>
+          <p:nvPr/>
+        </p:nvSpPr>
+        <p:spPr>
+          <a:xfrm>
+            <a:off x="731520" y="1234440"/>
+            <a:ext cx="3291840" cy="2103120"/>
+          </a:xfrm>
+          <a:prstGeom prst="rect">
+            <a:avLst/>
+          </a:prstGeom>
+          <a:solidFill>
+            <a:srgbClr val="FFFFFF"/>
+          </a:solidFill>
+          <a:ln w="12700">
+            <a:solidFill>
+              <a:srgbClr val="E2E8F0"/>
+            </a:solidFill>
+          </a:ln>
+        </p:spPr>
+        <p:style>
+          <a:lnRef idx="1">
+            <a:schemeClr val="accent1"/>
+          </a:lnRef>
+          <a:fillRef idx="3">
+            <a:schemeClr val="accent1"/>
+          </a:fillRef>
+          <a:effectRef idx="2">
+            <a:schemeClr val="accent1"/>
+          </a:effectRef>
+          <a:fontRef idx="minor">
+            <a:schemeClr val="lt1"/>
+          </a:fontRef>
+        </p:style>
+        <p:txBody>
+          <a:bodyPr rtlCol="0" anchor="ctr"/>
+          <a:lstStyle/>
+          <a:p>
+            <a:pPr algn="ctr"/>
+          </a:p>
+        </p:txBody>
+      </p:sp>
+      <p:sp>
+        <p:nvSpPr>
+          <p:cNvPr id="5" name="TextBox 4"/>
           <p:cNvSpPr txBox="1"/>
           <p:nvPr/>
         </p:nvSpPr>
         <p:spPr>
           <a:xfrm>
-            <a:off x="731520" y="1280160"/>
-            <a:ext cx="10698480" cy="4754880"/>
+            <a:off x="914400" y="1371600"/>
+            <a:ext cx="2926080" cy="365760"/>
           </a:xfrm>
           <a:prstGeom prst="rect">
             <a:avLst/>
@@ -5766,269 +5458,524 @@
           <a:lstStyle/>
           <a:p>
             <a:r>
-              <a:rPr sz="1400" b="0" i="0">
-                <a:solidFill>
-                  <a:srgbClr val="475569"/>
-                </a:solidFill>
-                <a:latin typeface="Times New Roman"/>
-                <a:ea typeface="宋体"/>
-              </a:rPr>
-              <a:t>每次 Claude Code 会话结束时自动运行的模块化后处理脚本链：</a:t>
-            </a:r>
-          </a:p>
-          <a:p>
-            <a:pPr>
-              <a:spcBef>
-                <a:spcPts val="600"/>
-              </a:spcBef>
-            </a:pPr>
-            <a:r>
-              <a:rPr sz="600" b="0" i="0">
-                <a:solidFill>
-                  <a:srgbClr val="475569"/>
-                </a:solidFill>
-                <a:latin typeface="Times New Roman"/>
-                <a:ea typeface="宋体"/>
-              </a:rPr>
-              <a:t/>
-            </a:r>
-          </a:p>
-          <a:p>
-            <a:pPr>
-              <a:spcBef>
-                <a:spcPts val="600"/>
-              </a:spcBef>
-            </a:pPr>
-            <a:r>
-              <a:rPr sz="1200" b="0" i="0">
-                <a:solidFill>
-                  <a:srgbClr val="475569"/>
-                </a:solidFill>
-                <a:latin typeface="Times New Roman"/>
-                <a:ea typeface="宋体"/>
-              </a:rPr>
-              <a:t>🔹 基础设施：00-gate（入口门禁）| 01-transcript-parse（转录解析）</a:t>
-            </a:r>
-          </a:p>
-          <a:p>
-            <a:pPr>
-              <a:spcBef>
-                <a:spcPts val="600"/>
-              </a:spcBef>
-            </a:pPr>
-            <a:r>
-              <a:rPr sz="1200" b="0" i="0">
-                <a:solidFill>
-                  <a:srgbClr val="475569"/>
-                </a:solidFill>
-                <a:latin typeface="Times New Roman"/>
-                <a:ea typeface="宋体"/>
-              </a:rPr>
-              <a:t>🔹 文件质量：20-claude-md | 21-memory | 22-git | 23-quality | 24-session | 25-project</a:t>
-            </a:r>
-          </a:p>
-          <a:p>
-            <a:pPr>
-              <a:spcBef>
-                <a:spcPts val="600"/>
-              </a:spcBef>
-            </a:pPr>
-            <a:r>
-              <a:rPr sz="1200" b="0" i="0">
-                <a:solidFill>
-                  <a:srgbClr val="475569"/>
-                </a:solidFill>
-                <a:latin typeface="Times New Roman"/>
-                <a:ea typeface="宋体"/>
-              </a:rPr>
-              <a:t>🔹 工作流：26-workflow（阶段门禁 + 产物完整性 + 未完成 task + checkpoint 断层）</a:t>
-            </a:r>
-          </a:p>
-          <a:p>
-            <a:pPr>
-              <a:spcBef>
-                <a:spcPts val="600"/>
-              </a:spcBef>
-            </a:pPr>
-            <a:r>
-              <a:rPr sz="1200" b="0" i="0">
-                <a:solidFill>
-                  <a:srgbClr val="475569"/>
-                </a:solidFill>
-                <a:latin typeface="Times New Roman"/>
-                <a:ea typeface="宋体"/>
-              </a:rPr>
-              <a:t>🔹 弱模型护栏：27-interactive-ui-check（检测跳过交互 gate → 矫正文件）</a:t>
-            </a:r>
-          </a:p>
-          <a:p>
-            <a:pPr>
-              <a:spcBef>
-                <a:spcPts val="600"/>
-              </a:spcBef>
-            </a:pPr>
-            <a:r>
-              <a:rPr sz="1200" b="0" i="0">
-                <a:solidFill>
-                  <a:srgbClr val="475569"/>
-                </a:solidFill>
-                <a:latin typeface="Times New Roman"/>
-                <a:ea typeface="宋体"/>
-              </a:rPr>
-              <a:t>🔹 弱模型合规：28-weak-model-compliance（L1 规则 + L2 自检 + L3 证据链 → 矫正文件）</a:t>
-            </a:r>
-          </a:p>
-          <a:p>
-            <a:pPr>
-              <a:spcBef>
-                <a:spcPts val="600"/>
-              </a:spcBef>
-            </a:pPr>
-            <a:r>
-              <a:rPr sz="1200" b="0" i="0">
-                <a:solidFill>
-                  <a:srgbClr val="475569"/>
-                </a:solidFill>
-                <a:latin typeface="Times New Roman"/>
-                <a:ea typeface="宋体"/>
-              </a:rPr>
-              <a:t>🔹 独立审查：29-independent-review（L3 外部模型盲审，异步调度）</a:t>
-            </a:r>
-          </a:p>
-          <a:p>
-            <a:pPr>
-              <a:spcBef>
-                <a:spcPts val="600"/>
-              </a:spcBef>
-            </a:pPr>
-            <a:r>
-              <a:rPr sz="1200" b="0" i="0">
-                <a:solidFill>
-                  <a:srgbClr val="475569"/>
-                </a:solidFill>
-                <a:latin typeface="Times New Roman"/>
-                <a:ea typeface="宋体"/>
-              </a:rPr>
-              <a:t>🔹 AI 分析：30-ai-analyze（提交结构化数据给 AI 深度分析）</a:t>
-            </a:r>
-          </a:p>
-          <a:p>
-            <a:pPr>
-              <a:spcBef>
-                <a:spcPts val="600"/>
-              </a:spcBef>
-            </a:pPr>
-            <a:r>
-              <a:rPr sz="1200" b="0" i="0">
-                <a:solidFill>
-                  <a:srgbClr val="475569"/>
-                </a:solidFill>
-                <a:latin typeface="Times New Roman"/>
-                <a:ea typeface="宋体"/>
-              </a:rPr>
-              <a:t>🔹 自动推进：31-auto-advance（auto_advance=true 时自动 transition）</a:t>
-            </a:r>
-          </a:p>
-          <a:p>
-            <a:pPr>
-              <a:spcBef>
-                <a:spcPts val="600"/>
-              </a:spcBef>
-            </a:pPr>
-            <a:r>
-              <a:rPr sz="1200" b="0" i="0">
-                <a:solidFill>
-                  <a:srgbClr val="475569"/>
-                </a:solidFill>
-                <a:latin typeface="Times New Roman"/>
-                <a:ea typeface="宋体"/>
-              </a:rPr>
-              <a:t>🔹 回退兜底：32-fallback-guard（mode=fallback 时自动标记 goal.status=done）</a:t>
-            </a:r>
-          </a:p>
-          <a:p>
-            <a:pPr>
-              <a:spcBef>
-                <a:spcPts val="600"/>
-              </a:spcBef>
-            </a:pPr>
-            <a:r>
-              <a:rPr sz="1200" b="0" i="0">
-                <a:solidFill>
-                  <a:srgbClr val="475569"/>
-                </a:solidFill>
-                <a:latin typeface="Times New Roman"/>
-                <a:ea typeface="宋体"/>
-              </a:rPr>
-              <a:t>🔹 状态完整性：33-flow-active-integrity（.flow-active ↔ 磁盘产物交叉验证 + 时效性检测）</a:t>
-            </a:r>
-          </a:p>
-          <a:p>
-            <a:pPr>
-              <a:spcBef>
-                <a:spcPts val="600"/>
-              </a:spcBef>
-            </a:pPr>
-            <a:r>
-              <a:rPr sz="1200" b="0" i="0">
-                <a:solidFill>
-                  <a:srgbClr val="475569"/>
-                </a:solidFill>
-                <a:latin typeface="Times New Roman"/>
-                <a:ea typeface="宋体"/>
-              </a:rPr>
-              <a:t>🔹 报告：99-report（生成 stop-hook-report.md + token 用量展示）</a:t>
-            </a:r>
-          </a:p>
-          <a:p>
-            <a:pPr>
-              <a:spcBef>
-                <a:spcPts val="600"/>
-              </a:spcBef>
-            </a:pPr>
-            <a:r>
-              <a:rPr sz="600" b="0" i="0">
-                <a:solidFill>
-                  <a:srgbClr val="475569"/>
-                </a:solidFill>
-                <a:latin typeface="Times New Roman"/>
-                <a:ea typeface="宋体"/>
-              </a:rPr>
-              <a:t/>
-            </a:r>
-          </a:p>
-          <a:p>
-            <a:pPr>
-              <a:spcBef>
-                <a:spcPts val="600"/>
-              </a:spcBef>
-            </a:pPr>
-            <a:r>
-              <a:rPr sz="1200" b="1" i="0">
-                <a:solidFill>
-                  <a:srgbClr val="1E293B"/>
-                </a:solidFill>
-                <a:latin typeface="Times New Roman"/>
-                <a:ea typeface="宋体"/>
-              </a:rPr>
-              <a:t>PreToolUse Hook（2 模块）：independent-review-gate（硬拦截 commit/PR/切阶段）+ auto-checkpoint（Write/Edit 前自动写 interrupt）</a:t>
-            </a:r>
-          </a:p>
-          <a:p>
-            <a:pPr>
-              <a:spcBef>
-                <a:spcPts val="600"/>
-              </a:spcBef>
-            </a:pPr>
-            <a:r>
-              <a:rPr sz="1200" b="1" i="0">
-                <a:solidFill>
-                  <a:srgbClr val="1E293B"/>
-                </a:solidFill>
-                <a:latin typeface="Times New Roman"/>
-                <a:ea typeface="宋体"/>
-              </a:rPr>
-              <a:t>SessionStart Hook（2 模块）：flow-kit-resume（中断恢复 + 矫正注入）+ stop-report-reminder（报告提醒）</a:t>
+              <a:rPr sz="1400" b="1" i="0">
+                <a:solidFill>
+                  <a:srgbClr val="2563EB"/>
+                </a:solidFill>
+                <a:latin typeface="Times New Roman"/>
+                <a:ea typeface="宋体"/>
+              </a:rPr>
+              <a:t>I-intel · 入场扫描</a:t>
+            </a:r>
+          </a:p>
+        </p:txBody>
+      </p:sp>
+      <p:sp>
+        <p:nvSpPr>
+          <p:cNvPr id="6" name="TextBox 5"/>
+          <p:cNvSpPr txBox="1"/>
+          <p:nvPr/>
+        </p:nvSpPr>
+        <p:spPr>
+          <a:xfrm>
+            <a:off x="914400" y="1783080"/>
+            <a:ext cx="2926080" cy="1371600"/>
+          </a:xfrm>
+          <a:prstGeom prst="rect">
+            <a:avLst/>
+          </a:prstGeom>
+          <a:noFill/>
+        </p:spPr>
+        <p:txBody>
+          <a:bodyPr wrap="square">
+            <a:spAutoFit/>
+          </a:bodyPr>
+          <a:lstStyle/>
+          <a:p>
+            <a:r>
+              <a:rPr sz="1000" b="0" i="0">
+                <a:solidFill>
+                  <a:srgbClr val="475569"/>
+                </a:solidFill>
+                <a:latin typeface="Times New Roman"/>
+                <a:ea typeface="宋体"/>
+              </a:rPr>
+              <a:t>生成 CONTEXT.md
+术语表 + 既有抽象索引
++ 禁动清单 + 命名约定
+首次使用 flow-kit 必跑</a:t>
+            </a:r>
+          </a:p>
+        </p:txBody>
+      </p:sp>
+      <p:sp>
+        <p:nvSpPr>
+          <p:cNvPr id="7" name="Rectangle 6"/>
+          <p:cNvSpPr/>
+          <p:nvPr/>
+        </p:nvSpPr>
+        <p:spPr>
+          <a:xfrm>
+            <a:off x="4251960" y="1234440"/>
+            <a:ext cx="3291840" cy="2103120"/>
+          </a:xfrm>
+          <a:prstGeom prst="rect">
+            <a:avLst/>
+          </a:prstGeom>
+          <a:solidFill>
+            <a:srgbClr val="FFFFFF"/>
+          </a:solidFill>
+          <a:ln w="12700">
+            <a:solidFill>
+              <a:srgbClr val="E2E8F0"/>
+            </a:solidFill>
+          </a:ln>
+        </p:spPr>
+        <p:style>
+          <a:lnRef idx="1">
+            <a:schemeClr val="accent1"/>
+          </a:lnRef>
+          <a:fillRef idx="3">
+            <a:schemeClr val="accent1"/>
+          </a:fillRef>
+          <a:effectRef idx="2">
+            <a:schemeClr val="accent1"/>
+          </a:effectRef>
+          <a:fontRef idx="minor">
+            <a:schemeClr val="lt1"/>
+          </a:fontRef>
+        </p:style>
+        <p:txBody>
+          <a:bodyPr rtlCol="0" anchor="ctr"/>
+          <a:lstStyle/>
+          <a:p>
+            <a:pPr algn="ctr"/>
+          </a:p>
+        </p:txBody>
+      </p:sp>
+      <p:sp>
+        <p:nvSpPr>
+          <p:cNvPr id="8" name="TextBox 7"/>
+          <p:cNvSpPr txBox="1"/>
+          <p:nvPr/>
+        </p:nvSpPr>
+        <p:spPr>
+          <a:xfrm>
+            <a:off x="4434840" y="1371600"/>
+            <a:ext cx="2926080" cy="365760"/>
+          </a:xfrm>
+          <a:prstGeom prst="rect">
+            <a:avLst/>
+          </a:prstGeom>
+          <a:noFill/>
+        </p:spPr>
+        <p:txBody>
+          <a:bodyPr wrap="square">
+            <a:spAutoFit/>
+          </a:bodyPr>
+          <a:lstStyle/>
+          <a:p>
+            <a:r>
+              <a:rPr sz="1400" b="1" i="0">
+                <a:solidFill>
+                  <a:srgbClr val="2563EB"/>
+                </a:solidFill>
+                <a:latin typeface="Times New Roman"/>
+                <a:ea typeface="宋体"/>
+              </a:rPr>
+              <a:t>M-health · 健康巡检</a:t>
+            </a:r>
+          </a:p>
+        </p:txBody>
+      </p:sp>
+      <p:sp>
+        <p:nvSpPr>
+          <p:cNvPr id="9" name="TextBox 8"/>
+          <p:cNvSpPr txBox="1"/>
+          <p:nvPr/>
+        </p:nvSpPr>
+        <p:spPr>
+          <a:xfrm>
+            <a:off x="4434840" y="1783080"/>
+            <a:ext cx="2926080" cy="1371600"/>
+          </a:xfrm>
+          <a:prstGeom prst="rect">
+            <a:avLst/>
+          </a:prstGeom>
+          <a:noFill/>
+        </p:spPr>
+        <p:txBody>
+          <a:bodyPr wrap="square">
+            <a:spAutoFit/>
+          </a:bodyPr>
+          <a:lstStyle/>
+          <a:p>
+            <a:r>
+              <a:rPr sz="1000" b="0" i="0">
+                <a:solidFill>
+                  <a:srgbClr val="475569"/>
+                </a:solidFill>
+                <a:latin typeface="Times New Roman"/>
+                <a:ea typeface="宋体"/>
+              </a:rPr>
+              <a:t>代码库健康诊断 + 技术债盘点
+快速/标准/深度三种模式
+brooks-lint 优先，AI 内置回退
+冗余扫描：jscpd/knip/depcheck</a:t>
+            </a:r>
+          </a:p>
+        </p:txBody>
+      </p:sp>
+      <p:sp>
+        <p:nvSpPr>
+          <p:cNvPr id="10" name="Rectangle 9"/>
+          <p:cNvSpPr/>
+          <p:nvPr/>
+        </p:nvSpPr>
+        <p:spPr>
+          <a:xfrm>
+            <a:off x="7772400" y="1234440"/>
+            <a:ext cx="3291840" cy="2103120"/>
+          </a:xfrm>
+          <a:prstGeom prst="rect">
+            <a:avLst/>
+          </a:prstGeom>
+          <a:solidFill>
+            <a:srgbClr val="FFFFFF"/>
+          </a:solidFill>
+          <a:ln w="12700">
+            <a:solidFill>
+              <a:srgbClr val="E2E8F0"/>
+            </a:solidFill>
+          </a:ln>
+        </p:spPr>
+        <p:style>
+          <a:lnRef idx="1">
+            <a:schemeClr val="accent1"/>
+          </a:lnRef>
+          <a:fillRef idx="3">
+            <a:schemeClr val="accent1"/>
+          </a:fillRef>
+          <a:effectRef idx="2">
+            <a:schemeClr val="accent1"/>
+          </a:effectRef>
+          <a:fontRef idx="minor">
+            <a:schemeClr val="lt1"/>
+          </a:fontRef>
+        </p:style>
+        <p:txBody>
+          <a:bodyPr rtlCol="0" anchor="ctr"/>
+          <a:lstStyle/>
+          <a:p>
+            <a:pPr algn="ctr"/>
+          </a:p>
+        </p:txBody>
+      </p:sp>
+      <p:sp>
+        <p:nvSpPr>
+          <p:cNvPr id="11" name="TextBox 10"/>
+          <p:cNvSpPr txBox="1"/>
+          <p:nvPr/>
+        </p:nvSpPr>
+        <p:spPr>
+          <a:xfrm>
+            <a:off x="7955280" y="1371600"/>
+            <a:ext cx="2926080" cy="365760"/>
+          </a:xfrm>
+          <a:prstGeom prst="rect">
+            <a:avLst/>
+          </a:prstGeom>
+          <a:noFill/>
+        </p:spPr>
+        <p:txBody>
+          <a:bodyPr wrap="square">
+            <a:spAutoFit/>
+          </a:bodyPr>
+          <a:lstStyle/>
+          <a:p>
+            <a:r>
+              <a:rPr sz="1400" b="1" i="0">
+                <a:solidFill>
+                  <a:srgbClr val="2563EB"/>
+                </a:solidFill>
+                <a:latin typeface="Times New Roman"/>
+                <a:ea typeface="宋体"/>
+              </a:rPr>
+              <a:t>A-architect · 架构文档</a:t>
+            </a:r>
+          </a:p>
+        </p:txBody>
+      </p:sp>
+      <p:sp>
+        <p:nvSpPr>
+          <p:cNvPr id="12" name="TextBox 11"/>
+          <p:cNvSpPr txBox="1"/>
+          <p:nvPr/>
+        </p:nvSpPr>
+        <p:spPr>
+          <a:xfrm>
+            <a:off x="7955280" y="1783080"/>
+            <a:ext cx="2926080" cy="1371600"/>
+          </a:xfrm>
+          <a:prstGeom prst="rect">
+            <a:avLst/>
+          </a:prstGeom>
+          <a:noFill/>
+        </p:spPr>
+        <p:txBody>
+          <a:bodyPr wrap="square">
+            <a:spAutoFit/>
+          </a:bodyPr>
+          <a:lstStyle/>
+          <a:p>
+            <a:r>
+              <a:rPr sz="1000" b="0" i="0">
+                <a:solidFill>
+                  <a:srgbClr val="475569"/>
+                </a:solidFill>
+                <a:latin typeface="Times New Roman"/>
+                <a:ea typeface="宋体"/>
+              </a:rPr>
+              <a:t>生成 ARCHITECTURE.md + ADR
+系统概览 + 模块清单
++ 跨模块契约 + 容量边界
+首次/重构时建立</a:t>
+            </a:r>
+          </a:p>
+        </p:txBody>
+      </p:sp>
+      <p:sp>
+        <p:nvSpPr>
+          <p:cNvPr id="13" name="Rectangle 12"/>
+          <p:cNvSpPr/>
+          <p:nvPr/>
+        </p:nvSpPr>
+        <p:spPr>
+          <a:xfrm>
+            <a:off x="731520" y="3566160"/>
+            <a:ext cx="3291840" cy="2103120"/>
+          </a:xfrm>
+          <a:prstGeom prst="rect">
+            <a:avLst/>
+          </a:prstGeom>
+          <a:solidFill>
+            <a:srgbClr val="FFFFFF"/>
+          </a:solidFill>
+          <a:ln w="12700">
+            <a:solidFill>
+              <a:srgbClr val="E2E8F0"/>
+            </a:solidFill>
+          </a:ln>
+        </p:spPr>
+        <p:style>
+          <a:lnRef idx="1">
+            <a:schemeClr val="accent1"/>
+          </a:lnRef>
+          <a:fillRef idx="3">
+            <a:schemeClr val="accent1"/>
+          </a:fillRef>
+          <a:effectRef idx="2">
+            <a:schemeClr val="accent1"/>
+          </a:effectRef>
+          <a:fontRef idx="minor">
+            <a:schemeClr val="lt1"/>
+          </a:fontRef>
+        </p:style>
+        <p:txBody>
+          <a:bodyPr rtlCol="0" anchor="ctr"/>
+          <a:lstStyle/>
+          <a:p>
+            <a:pPr algn="ctr"/>
+          </a:p>
+        </p:txBody>
+      </p:sp>
+      <p:sp>
+        <p:nvSpPr>
+          <p:cNvPr id="14" name="TextBox 13"/>
+          <p:cNvSpPr txBox="1"/>
+          <p:nvPr/>
+        </p:nvSpPr>
+        <p:spPr>
+          <a:xfrm>
+            <a:off x="914400" y="3703320"/>
+            <a:ext cx="2926080" cy="365760"/>
+          </a:xfrm>
+          <a:prstGeom prst="rect">
+            <a:avLst/>
+          </a:prstGeom>
+          <a:noFill/>
+        </p:spPr>
+        <p:txBody>
+          <a:bodyPr wrap="square">
+            <a:spAutoFit/>
+          </a:bodyPr>
+          <a:lstStyle/>
+          <a:p>
+            <a:r>
+              <a:rPr sz="1400" b="1" i="0">
+                <a:solidFill>
+                  <a:srgbClr val="2563EB"/>
+                </a:solidFill>
+                <a:latin typeface="Times New Roman"/>
+                <a:ea typeface="宋体"/>
+              </a:rPr>
+              <a:t>A-evolve · 架构沉淀</a:t>
+            </a:r>
+          </a:p>
+        </p:txBody>
+      </p:sp>
+      <p:sp>
+        <p:nvSpPr>
+          <p:cNvPr id="15" name="TextBox 14"/>
+          <p:cNvSpPr txBox="1"/>
+          <p:nvPr/>
+        </p:nvSpPr>
+        <p:spPr>
+          <a:xfrm>
+            <a:off x="914400" y="4114800"/>
+            <a:ext cx="2926080" cy="1371600"/>
+          </a:xfrm>
+          <a:prstGeom prst="rect">
+            <a:avLst/>
+          </a:prstGeom>
+          <a:noFill/>
+        </p:spPr>
+        <p:txBody>
+          <a:bodyPr wrap="square">
+            <a:spAutoFit/>
+          </a:bodyPr>
+          <a:lstStyle/>
+          <a:p>
+            <a:r>
+              <a:rPr sz="1000" b="0" i="0">
+                <a:solidFill>
+                  <a:srgbClr val="475569"/>
+                </a:solidFill>
+                <a:latin typeface="Times New Roman"/>
+                <a:ea typeface="宋体"/>
+              </a:rPr>
+              <a:t>扫描已归档 DESIGN.md §9
+聚合分类 → 用户 review
+→ patch CONTEXT.md
++ ARCHITECTURE.md</a:t>
+            </a:r>
+          </a:p>
+        </p:txBody>
+      </p:sp>
+      <p:sp>
+        <p:nvSpPr>
+          <p:cNvPr id="16" name="Rectangle 15"/>
+          <p:cNvSpPr/>
+          <p:nvPr/>
+        </p:nvSpPr>
+        <p:spPr>
+          <a:xfrm>
+            <a:off x="4251960" y="3566160"/>
+            <a:ext cx="3291840" cy="2103120"/>
+          </a:xfrm>
+          <a:prstGeom prst="rect">
+            <a:avLst/>
+          </a:prstGeom>
+          <a:solidFill>
+            <a:srgbClr val="FFFFFF"/>
+          </a:solidFill>
+          <a:ln w="12700">
+            <a:solidFill>
+              <a:srgbClr val="E2E8F0"/>
+            </a:solidFill>
+          </a:ln>
+        </p:spPr>
+        <p:style>
+          <a:lnRef idx="1">
+            <a:schemeClr val="accent1"/>
+          </a:lnRef>
+          <a:fillRef idx="3">
+            <a:schemeClr val="accent1"/>
+          </a:fillRef>
+          <a:effectRef idx="2">
+            <a:schemeClr val="accent1"/>
+          </a:effectRef>
+          <a:fontRef idx="minor">
+            <a:schemeClr val="lt1"/>
+          </a:fontRef>
+        </p:style>
+        <p:txBody>
+          <a:bodyPr rtlCol="0" anchor="ctr"/>
+          <a:lstStyle/>
+          <a:p>
+            <a:pPr algn="ctr"/>
+          </a:p>
+        </p:txBody>
+      </p:sp>
+      <p:sp>
+        <p:nvSpPr>
+          <p:cNvPr id="17" name="TextBox 16"/>
+          <p:cNvSpPr txBox="1"/>
+          <p:nvPr/>
+        </p:nvSpPr>
+        <p:spPr>
+          <a:xfrm>
+            <a:off x="4434840" y="3703320"/>
+            <a:ext cx="2926080" cy="365760"/>
+          </a:xfrm>
+          <a:prstGeom prst="rect">
+            <a:avLst/>
+          </a:prstGeom>
+          <a:noFill/>
+        </p:spPr>
+        <p:txBody>
+          <a:bodyPr wrap="square">
+            <a:spAutoFit/>
+          </a:bodyPr>
+          <a:lstStyle/>
+          <a:p>
+            <a:r>
+              <a:rPr sz="1400" b="1" i="0">
+                <a:solidFill>
+                  <a:srgbClr val="2563EB"/>
+                </a:solidFill>
+                <a:latin typeface="Times New Roman"/>
+                <a:ea typeface="宋体"/>
+              </a:rPr>
+              <a:t>L-restyle · 视觉重构</a:t>
+            </a:r>
+          </a:p>
+        </p:txBody>
+      </p:sp>
+      <p:sp>
+        <p:nvSpPr>
+          <p:cNvPr id="18" name="TextBox 17"/>
+          <p:cNvSpPr txBox="1"/>
+          <p:nvPr/>
+        </p:nvSpPr>
+        <p:spPr>
+          <a:xfrm>
+            <a:off x="4434840" y="4114800"/>
+            <a:ext cx="2926080" cy="1371600"/>
+          </a:xfrm>
+          <a:prstGeom prst="rect">
+            <a:avLst/>
+          </a:prstGeom>
+          <a:noFill/>
+        </p:spPr>
+        <p:txBody>
+          <a:bodyPr wrap="square">
+            <a:spAutoFit/>
+          </a:bodyPr>
+          <a:lstStyle/>
+          <a:p>
+            <a:r>
+              <a:rPr sz="1000" b="0" i="0">
+                <a:solidFill>
+                  <a:srgbClr val="475569"/>
+                </a:solidFill>
+                <a:latin typeface="Times New Roman"/>
+                <a:ea typeface="宋体"/>
+              </a:rPr>
+              <a:t>保留功能，重做 UI 视觉
+自动生成 change-id
+v1→v2 视觉对照表
+组件库迁移/品牌升级适用</a:t>
             </a:r>
           </a:p>
         </p:txBody>
@@ -6124,66 +6071,21 @@
                 <a:latin typeface="Times New Roman"/>
                 <a:ea typeface="宋体"/>
               </a:rPr>
-              <a:t>brooks-lint 代码审查插件</a:t>
-            </a:r>
-          </a:p>
-        </p:txBody>
-      </p:sp>
-      <p:sp>
-        <p:nvSpPr>
-          <p:cNvPr id="4" name="Rectangle 3"/>
-          <p:cNvSpPr/>
-          <p:nvPr/>
-        </p:nvSpPr>
-        <p:spPr>
-          <a:xfrm>
-            <a:off x="731520" y="1234440"/>
-            <a:ext cx="3291840" cy="2103120"/>
-          </a:xfrm>
-          <a:prstGeom prst="rect">
-            <a:avLst/>
-          </a:prstGeom>
-          <a:solidFill>
-            <a:srgbClr val="FFFFFF"/>
-          </a:solidFill>
-          <a:ln w="12700">
-            <a:solidFill>
-              <a:srgbClr val="E2E8F0"/>
-            </a:solidFill>
-          </a:ln>
-        </p:spPr>
-        <p:style>
-          <a:lnRef idx="1">
-            <a:schemeClr val="accent1"/>
-          </a:lnRef>
-          <a:fillRef idx="3">
-            <a:schemeClr val="accent1"/>
-          </a:fillRef>
-          <a:effectRef idx="2">
-            <a:schemeClr val="accent1"/>
-          </a:effectRef>
-          <a:fontRef idx="minor">
-            <a:schemeClr val="lt1"/>
-          </a:fontRef>
-        </p:style>
-        <p:txBody>
-          <a:bodyPr rtlCol="0" anchor="ctr"/>
-          <a:lstStyle/>
-          <a:p>
-            <a:pPr algn="ctr"/>
-          </a:p>
-        </p:txBody>
-      </p:sp>
-      <p:sp>
-        <p:nvSpPr>
-          <p:cNvPr id="5" name="TextBox 4"/>
+              <a:t>Stop Hook 系统（17 模块）</a:t>
+            </a:r>
+          </a:p>
+        </p:txBody>
+      </p:sp>
+      <p:sp>
+        <p:nvSpPr>
+          <p:cNvPr id="4" name="TextBox 3"/>
           <p:cNvSpPr txBox="1"/>
           <p:nvPr/>
         </p:nvSpPr>
         <p:spPr>
           <a:xfrm>
-            <a:off x="914400" y="1371600"/>
-            <a:ext cx="2926080" cy="365760"/>
+            <a:off x="731520" y="1280160"/>
+            <a:ext cx="10698480" cy="4754880"/>
           </a:xfrm>
           <a:prstGeom prst="rect">
             <a:avLst/>
@@ -6197,28 +6099,283 @@
           <a:lstStyle/>
           <a:p>
             <a:r>
-              <a:rPr sz="1400" b="1" i="0">
-                <a:solidFill>
-                  <a:srgbClr val="2563EB"/>
-                </a:solidFill>
-                <a:latin typeface="Times New Roman"/>
-                <a:ea typeface="宋体"/>
-              </a:rPr>
-              <a:t>/brooks-review</a:t>
-            </a:r>
-          </a:p>
-        </p:txBody>
-      </p:sp>
-      <p:sp>
-        <p:nvSpPr>
-          <p:cNvPr id="6" name="TextBox 5"/>
+              <a:rPr sz="1400" b="0" i="0">
+                <a:solidFill>
+                  <a:srgbClr val="475569"/>
+                </a:solidFill>
+                <a:latin typeface="Times New Roman"/>
+                <a:ea typeface="宋体"/>
+              </a:rPr>
+              <a:t>每次 Claude Code 会话结束时自动运行的模块化后处理脚本链：</a:t>
+            </a:r>
+          </a:p>
+          <a:p>
+            <a:pPr>
+              <a:spcBef>
+                <a:spcPts val="600"/>
+              </a:spcBef>
+            </a:pPr>
+            <a:r>
+              <a:rPr sz="600" b="0" i="0">
+                <a:solidFill>
+                  <a:srgbClr val="475569"/>
+                </a:solidFill>
+                <a:latin typeface="Times New Roman"/>
+                <a:ea typeface="宋体"/>
+              </a:rPr>
+              <a:t/>
+            </a:r>
+          </a:p>
+          <a:p>
+            <a:pPr>
+              <a:spcBef>
+                <a:spcPts val="600"/>
+              </a:spcBef>
+            </a:pPr>
+            <a:r>
+              <a:rPr sz="1200" b="0" i="0">
+                <a:solidFill>
+                  <a:srgbClr val="475569"/>
+                </a:solidFill>
+                <a:latin typeface="Times New Roman"/>
+                <a:ea typeface="宋体"/>
+              </a:rPr>
+              <a:t>🔹 基础设施：00-gate（入口门禁）| 01-transcript-parse（转录解析）</a:t>
+            </a:r>
+          </a:p>
+          <a:p>
+            <a:pPr>
+              <a:spcBef>
+                <a:spcPts val="600"/>
+              </a:spcBef>
+            </a:pPr>
+            <a:r>
+              <a:rPr sz="1200" b="0" i="0">
+                <a:solidFill>
+                  <a:srgbClr val="475569"/>
+                </a:solidFill>
+                <a:latin typeface="Times New Roman"/>
+                <a:ea typeface="宋体"/>
+              </a:rPr>
+              <a:t>🔹 文件质量：20-claude-md | 21-memory | 22-git | 23-quality | 24-session | 25-project</a:t>
+            </a:r>
+          </a:p>
+          <a:p>
+            <a:pPr>
+              <a:spcBef>
+                <a:spcPts val="600"/>
+              </a:spcBef>
+            </a:pPr>
+            <a:r>
+              <a:rPr sz="1200" b="0" i="0">
+                <a:solidFill>
+                  <a:srgbClr val="475569"/>
+                </a:solidFill>
+                <a:latin typeface="Times New Roman"/>
+                <a:ea typeface="宋体"/>
+              </a:rPr>
+              <a:t>🔹 工作流：26-workflow（阶段门禁 + 产物完整性 + 未完成 task + checkpoint 断层）</a:t>
+            </a:r>
+          </a:p>
+          <a:p>
+            <a:pPr>
+              <a:spcBef>
+                <a:spcPts val="600"/>
+              </a:spcBef>
+            </a:pPr>
+            <a:r>
+              <a:rPr sz="1200" b="0" i="0">
+                <a:solidFill>
+                  <a:srgbClr val="475569"/>
+                </a:solidFill>
+                <a:latin typeface="Times New Roman"/>
+                <a:ea typeface="宋体"/>
+              </a:rPr>
+              <a:t>🔹 弱模型护栏：27-interactive-ui-check（检测跳过交互 gate → 矫正文件）</a:t>
+            </a:r>
+          </a:p>
+          <a:p>
+            <a:pPr>
+              <a:spcBef>
+                <a:spcPts val="600"/>
+              </a:spcBef>
+            </a:pPr>
+            <a:r>
+              <a:rPr sz="1200" b="0" i="0">
+                <a:solidFill>
+                  <a:srgbClr val="475569"/>
+                </a:solidFill>
+                <a:latin typeface="Times New Roman"/>
+                <a:ea typeface="宋体"/>
+              </a:rPr>
+              <a:t>🔹 弱模型合规：28-weak-model-compliance（L1 规则 + L2 自检 + L3 证据链 → 矫正文件）</a:t>
+            </a:r>
+          </a:p>
+          <a:p>
+            <a:pPr>
+              <a:spcBef>
+                <a:spcPts val="600"/>
+              </a:spcBef>
+            </a:pPr>
+            <a:r>
+              <a:rPr sz="1200" b="0" i="0">
+                <a:solidFill>
+                  <a:srgbClr val="475569"/>
+                </a:solidFill>
+                <a:latin typeface="Times New Roman"/>
+                <a:ea typeface="宋体"/>
+              </a:rPr>
+              <a:t>🔹 独立审查：29-independent-review（L3 外部模型盲审，异步调度）</a:t>
+            </a:r>
+          </a:p>
+          <a:p>
+            <a:pPr>
+              <a:spcBef>
+                <a:spcPts val="600"/>
+              </a:spcBef>
+            </a:pPr>
+            <a:r>
+              <a:rPr sz="1200" b="0" i="0">
+                <a:solidFill>
+                  <a:srgbClr val="475569"/>
+                </a:solidFill>
+                <a:latin typeface="Times New Roman"/>
+                <a:ea typeface="宋体"/>
+              </a:rPr>
+              <a:t>🔹 AI 分析：30-ai-analyze（提交结构化数据给 AI 深度分析）</a:t>
+            </a:r>
+          </a:p>
+          <a:p>
+            <a:pPr>
+              <a:spcBef>
+                <a:spcPts val="600"/>
+              </a:spcBef>
+            </a:pPr>
+            <a:r>
+              <a:rPr sz="1200" b="0" i="0">
+                <a:solidFill>
+                  <a:srgbClr val="475569"/>
+                </a:solidFill>
+                <a:latin typeface="Times New Roman"/>
+                <a:ea typeface="宋体"/>
+              </a:rPr>
+              <a:t>🔹 自动推进：31-auto-advance（auto_advance=true 时自动 transition）</a:t>
+            </a:r>
+          </a:p>
+          <a:p>
+            <a:pPr>
+              <a:spcBef>
+                <a:spcPts val="600"/>
+              </a:spcBef>
+            </a:pPr>
+            <a:r>
+              <a:rPr sz="1200" b="0" i="0">
+                <a:solidFill>
+                  <a:srgbClr val="475569"/>
+                </a:solidFill>
+                <a:latin typeface="Times New Roman"/>
+                <a:ea typeface="宋体"/>
+              </a:rPr>
+              <a:t>🔹 回退兜底：32-fallback-guard（mode=fallback 时自动标记 goal.status=done）</a:t>
+            </a:r>
+          </a:p>
+          <a:p>
+            <a:pPr>
+              <a:spcBef>
+                <a:spcPts val="600"/>
+              </a:spcBef>
+            </a:pPr>
+            <a:r>
+              <a:rPr sz="1200" b="0" i="0">
+                <a:solidFill>
+                  <a:srgbClr val="475569"/>
+                </a:solidFill>
+                <a:latin typeface="Times New Roman"/>
+                <a:ea typeface="宋体"/>
+              </a:rPr>
+              <a:t>🔹 状态完整性：33-flow-active-integrity（.flow-active ↔ 磁盘产物交叉验证 + 时效性检测）</a:t>
+            </a:r>
+          </a:p>
+          <a:p>
+            <a:pPr>
+              <a:spcBef>
+                <a:spcPts val="600"/>
+              </a:spcBef>
+            </a:pPr>
+            <a:r>
+              <a:rPr sz="1200" b="0" i="0">
+                <a:solidFill>
+                  <a:srgbClr val="475569"/>
+                </a:solidFill>
+                <a:latin typeface="Times New Roman"/>
+                <a:ea typeface="宋体"/>
+              </a:rPr>
+              <a:t>🔹 报告：99-report（生成 stop-hook-report.md + token 用量展示）</a:t>
+            </a:r>
+          </a:p>
+          <a:p>
+            <a:pPr>
+              <a:spcBef>
+                <a:spcPts val="600"/>
+              </a:spcBef>
+            </a:pPr>
+            <a:r>
+              <a:rPr sz="600" b="0" i="0">
+                <a:solidFill>
+                  <a:srgbClr val="475569"/>
+                </a:solidFill>
+                <a:latin typeface="Times New Roman"/>
+                <a:ea typeface="宋体"/>
+              </a:rPr>
+              <a:t/>
+            </a:r>
+          </a:p>
+          <a:p>
+            <a:pPr>
+              <a:spcBef>
+                <a:spcPts val="600"/>
+              </a:spcBef>
+            </a:pPr>
+            <a:r>
+              <a:rPr sz="1200" b="1" i="0">
+                <a:solidFill>
+                  <a:srgbClr val="1E293B"/>
+                </a:solidFill>
+                <a:latin typeface="Times New Roman"/>
+                <a:ea typeface="宋体"/>
+              </a:rPr>
+              <a:t>PreToolUse Hook（2 模块）：independent-review-gate（硬拦截 commit/PR/切阶段）+ auto-checkpoint（Write/Edit 前自动写 interrupt）</a:t>
+            </a:r>
+          </a:p>
+          <a:p>
+            <a:pPr>
+              <a:spcBef>
+                <a:spcPts val="600"/>
+              </a:spcBef>
+            </a:pPr>
+            <a:r>
+              <a:rPr sz="1200" b="1" i="0">
+                <a:solidFill>
+                  <a:srgbClr val="1E293B"/>
+                </a:solidFill>
+                <a:latin typeface="Times New Roman"/>
+                <a:ea typeface="宋体"/>
+              </a:rPr>
+              <a:t>SessionStart Hook（2 模块）：flow-kit-resume（中断恢复 + 矫正注入）+ stop-report-reminder（报告提醒）</a:t>
+            </a:r>
+          </a:p>
+        </p:txBody>
+      </p:sp>
+      <p:sp>
+        <p:nvSpPr>
+          <p:cNvPr id="5" name="TextBox 4"/>
           <p:cNvSpPr txBox="1"/>
           <p:nvPr/>
         </p:nvSpPr>
         <p:spPr>
           <a:xfrm>
-            <a:off x="914400" y="1783080"/>
-            <a:ext cx="2926080" cy="1371600"/>
+            <a:off x="914400" y="5669280"/>
+            <a:ext cx="7315200" cy="548640"/>
           </a:xfrm>
           <a:prstGeom prst="rect">
             <a:avLst/>
@@ -6232,601 +6389,22 @@
           <a:lstStyle/>
           <a:p>
             <a:r>
-              <a:rPr sz="1000" b="0" i="0">
-                <a:solidFill>
-                  <a:srgbClr val="475569"/>
-                </a:solidFill>
-                <a:latin typeface="Times New Roman"/>
-                <a:ea typeface="宋体"/>
-              </a:rPr>
-              <a:t>PR 代码审查
-发现衰退风险和设计坏味
-Symptom→Source→Consequence→Remedy</a:t>
-            </a:r>
-          </a:p>
-        </p:txBody>
-      </p:sp>
-      <p:sp>
-        <p:nvSpPr>
-          <p:cNvPr id="7" name="Rectangle 6"/>
-          <p:cNvSpPr/>
-          <p:nvPr/>
-        </p:nvSpPr>
-        <p:spPr>
-          <a:xfrm>
-            <a:off x="4251960" y="1234440"/>
-            <a:ext cx="3291840" cy="2103120"/>
-          </a:xfrm>
-          <a:prstGeom prst="rect">
-            <a:avLst/>
-          </a:prstGeom>
-          <a:solidFill>
-            <a:srgbClr val="FFFFFF"/>
-          </a:solidFill>
-          <a:ln w="12700">
-            <a:solidFill>
-              <a:srgbClr val="E2E8F0"/>
-            </a:solidFill>
-          </a:ln>
-        </p:spPr>
-        <p:style>
-          <a:lnRef idx="1">
-            <a:schemeClr val="accent1"/>
-          </a:lnRef>
-          <a:fillRef idx="3">
-            <a:schemeClr val="accent1"/>
-          </a:fillRef>
-          <a:effectRef idx="2">
-            <a:schemeClr val="accent1"/>
-          </a:effectRef>
-          <a:fontRef idx="minor">
-            <a:schemeClr val="lt1"/>
-          </a:fontRef>
-        </p:style>
-        <p:txBody>
-          <a:bodyPr rtlCol="0" anchor="ctr"/>
-          <a:lstStyle/>
-          <a:p>
-            <a:pPr algn="ctr"/>
-          </a:p>
-        </p:txBody>
-      </p:sp>
-      <p:sp>
-        <p:nvSpPr>
-          <p:cNvPr id="8" name="TextBox 7"/>
-          <p:cNvSpPr txBox="1"/>
-          <p:nvPr/>
-        </p:nvSpPr>
-        <p:spPr>
-          <a:xfrm>
-            <a:off x="4434840" y="1371600"/>
-            <a:ext cx="2926080" cy="365760"/>
-          </a:xfrm>
-          <a:prstGeom prst="rect">
-            <a:avLst/>
-          </a:prstGeom>
-          <a:noFill/>
-        </p:spPr>
-        <p:txBody>
-          <a:bodyPr wrap="square">
-            <a:spAutoFit/>
-          </a:bodyPr>
-          <a:lstStyle/>
-          <a:p>
-            <a:r>
-              <a:rPr sz="1400" b="1" i="0">
-                <a:solidFill>
-                  <a:srgbClr val="2563EB"/>
-                </a:solidFill>
-                <a:latin typeface="Times New Roman"/>
-                <a:ea typeface="宋体"/>
-              </a:rPr>
-              <a:t>/brooks-audit</a:t>
-            </a:r>
-          </a:p>
-        </p:txBody>
-      </p:sp>
-      <p:sp>
-        <p:nvSpPr>
-          <p:cNvPr id="9" name="TextBox 8"/>
-          <p:cNvSpPr txBox="1"/>
-          <p:nvPr/>
-        </p:nvSpPr>
-        <p:spPr>
-          <a:xfrm>
-            <a:off x="4434840" y="1783080"/>
-            <a:ext cx="2926080" cy="1371600"/>
-          </a:xfrm>
-          <a:prstGeom prst="rect">
-            <a:avLst/>
-          </a:prstGeom>
-          <a:noFill/>
-        </p:spPr>
-        <p:txBody>
-          <a:bodyPr wrap="square">
-            <a:spAutoFit/>
-          </a:bodyPr>
-          <a:lstStyle/>
-          <a:p>
-            <a:r>
-              <a:rPr sz="1000" b="0" i="0">
-                <a:solidFill>
-                  <a:srgbClr val="475569"/>
-                </a:solidFill>
-                <a:latin typeface="Times New Roman"/>
-                <a:ea typeface="宋体"/>
-              </a:rPr>
-              <a:t>架构审计
-模块依赖图 + 分层完整性
-+ 循环依赖检测</a:t>
-            </a:r>
-          </a:p>
-        </p:txBody>
-      </p:sp>
-      <p:sp>
-        <p:nvSpPr>
-          <p:cNvPr id="10" name="Rectangle 9"/>
-          <p:cNvSpPr/>
-          <p:nvPr/>
-        </p:nvSpPr>
-        <p:spPr>
-          <a:xfrm>
-            <a:off x="7772400" y="1234440"/>
-            <a:ext cx="3291840" cy="2103120"/>
-          </a:xfrm>
-          <a:prstGeom prst="rect">
-            <a:avLst/>
-          </a:prstGeom>
-          <a:solidFill>
-            <a:srgbClr val="FFFFFF"/>
-          </a:solidFill>
-          <a:ln w="12700">
-            <a:solidFill>
-              <a:srgbClr val="E2E8F0"/>
-            </a:solidFill>
-          </a:ln>
-        </p:spPr>
-        <p:style>
-          <a:lnRef idx="1">
-            <a:schemeClr val="accent1"/>
-          </a:lnRef>
-          <a:fillRef idx="3">
-            <a:schemeClr val="accent1"/>
-          </a:fillRef>
-          <a:effectRef idx="2">
-            <a:schemeClr val="accent1"/>
-          </a:effectRef>
-          <a:fontRef idx="minor">
-            <a:schemeClr val="lt1"/>
-          </a:fontRef>
-        </p:style>
-        <p:txBody>
-          <a:bodyPr rtlCol="0" anchor="ctr"/>
-          <a:lstStyle/>
-          <a:p>
-            <a:pPr algn="ctr"/>
-          </a:p>
-        </p:txBody>
-      </p:sp>
-      <p:sp>
-        <p:nvSpPr>
-          <p:cNvPr id="11" name="TextBox 10"/>
-          <p:cNvSpPr txBox="1"/>
-          <p:nvPr/>
-        </p:nvSpPr>
-        <p:spPr>
-          <a:xfrm>
-            <a:off x="7955280" y="1371600"/>
-            <a:ext cx="2926080" cy="365760"/>
-          </a:xfrm>
-          <a:prstGeom prst="rect">
-            <a:avLst/>
-          </a:prstGeom>
-          <a:noFill/>
-        </p:spPr>
-        <p:txBody>
-          <a:bodyPr wrap="square">
-            <a:spAutoFit/>
-          </a:bodyPr>
-          <a:lstStyle/>
-          <a:p>
-            <a:r>
-              <a:rPr sz="1400" b="1" i="0">
-                <a:solidFill>
-                  <a:srgbClr val="2563EB"/>
-                </a:solidFill>
-                <a:latin typeface="Times New Roman"/>
-                <a:ea typeface="宋体"/>
-              </a:rPr>
-              <a:t>/brooks-debt</a:t>
-            </a:r>
-          </a:p>
-        </p:txBody>
-      </p:sp>
-      <p:sp>
-        <p:nvSpPr>
-          <p:cNvPr id="12" name="TextBox 11"/>
-          <p:cNvSpPr txBox="1"/>
-          <p:nvPr/>
-        </p:nvSpPr>
-        <p:spPr>
-          <a:xfrm>
-            <a:off x="7955280" y="1783080"/>
-            <a:ext cx="2926080" cy="1371600"/>
-          </a:xfrm>
-          <a:prstGeom prst="rect">
-            <a:avLst/>
-          </a:prstGeom>
-          <a:noFill/>
-        </p:spPr>
-        <p:txBody>
-          <a:bodyPr wrap="square">
-            <a:spAutoFit/>
-          </a:bodyPr>
-          <a:lstStyle/>
-          <a:p>
-            <a:r>
-              <a:rPr sz="1000" b="0" i="0">
-                <a:solidFill>
-                  <a:srgbClr val="475569"/>
-                </a:solidFill>
-                <a:latin typeface="Times New Roman"/>
-                <a:ea typeface="宋体"/>
-              </a:rPr>
-              <a:t>技术债评估
-分类 + 优先级排序
-构建重构路线图</a:t>
-            </a:r>
-          </a:p>
-        </p:txBody>
-      </p:sp>
-      <p:sp>
-        <p:nvSpPr>
-          <p:cNvPr id="13" name="Rectangle 12"/>
-          <p:cNvSpPr/>
-          <p:nvPr/>
-        </p:nvSpPr>
-        <p:spPr>
-          <a:xfrm>
-            <a:off x="731520" y="3566160"/>
-            <a:ext cx="3291840" cy="2103120"/>
-          </a:xfrm>
-          <a:prstGeom prst="rect">
-            <a:avLst/>
-          </a:prstGeom>
-          <a:solidFill>
-            <a:srgbClr val="FFFFFF"/>
-          </a:solidFill>
-          <a:ln w="12700">
-            <a:solidFill>
-              <a:srgbClr val="E2E8F0"/>
-            </a:solidFill>
-          </a:ln>
-        </p:spPr>
-        <p:style>
-          <a:lnRef idx="1">
-            <a:schemeClr val="accent1"/>
-          </a:lnRef>
-          <a:fillRef idx="3">
-            <a:schemeClr val="accent1"/>
-          </a:fillRef>
-          <a:effectRef idx="2">
-            <a:schemeClr val="accent1"/>
-          </a:effectRef>
-          <a:fontRef idx="minor">
-            <a:schemeClr val="lt1"/>
-          </a:fontRef>
-        </p:style>
-        <p:txBody>
-          <a:bodyPr rtlCol="0" anchor="ctr"/>
-          <a:lstStyle/>
-          <a:p>
-            <a:pPr algn="ctr"/>
-          </a:p>
-        </p:txBody>
-      </p:sp>
-      <p:sp>
-        <p:nvSpPr>
-          <p:cNvPr id="14" name="TextBox 13"/>
-          <p:cNvSpPr txBox="1"/>
-          <p:nvPr/>
-        </p:nvSpPr>
-        <p:spPr>
-          <a:xfrm>
-            <a:off x="914400" y="3703320"/>
-            <a:ext cx="2926080" cy="365760"/>
-          </a:xfrm>
-          <a:prstGeom prst="rect">
-            <a:avLst/>
-          </a:prstGeom>
-          <a:noFill/>
-        </p:spPr>
-        <p:txBody>
-          <a:bodyPr wrap="square">
-            <a:spAutoFit/>
-          </a:bodyPr>
-          <a:lstStyle/>
-          <a:p>
-            <a:r>
-              <a:rPr sz="1400" b="1" i="0">
-                <a:solidFill>
-                  <a:srgbClr val="2563EB"/>
-                </a:solidFill>
-                <a:latin typeface="Times New Roman"/>
-                <a:ea typeface="宋体"/>
-              </a:rPr>
-              <a:t>/brooks-test</a:t>
-            </a:r>
-          </a:p>
-        </p:txBody>
-      </p:sp>
-      <p:sp>
-        <p:nvSpPr>
-          <p:cNvPr id="15" name="TextBox 14"/>
-          <p:cNvSpPr txBox="1"/>
-          <p:nvPr/>
-        </p:nvSpPr>
-        <p:spPr>
-          <a:xfrm>
-            <a:off x="914400" y="4114800"/>
-            <a:ext cx="2926080" cy="1371600"/>
-          </a:xfrm>
-          <a:prstGeom prst="rect">
-            <a:avLst/>
-          </a:prstGeom>
-          <a:noFill/>
-        </p:spPr>
-        <p:txBody>
-          <a:bodyPr wrap="square">
-            <a:spAutoFit/>
-          </a:bodyPr>
-          <a:lstStyle/>
-          <a:p>
-            <a:r>
-              <a:rPr sz="1000" b="0" i="0">
-                <a:solidFill>
-                  <a:srgbClr val="475569"/>
-                </a:solidFill>
-                <a:latin typeface="Times New Roman"/>
-                <a:ea typeface="宋体"/>
-              </a:rPr>
-              <a:t>测试质量审查
-脆性测试 / mock 滥用
-/ 覆盖率幻觉诊断</a:t>
-            </a:r>
-          </a:p>
-        </p:txBody>
-      </p:sp>
-      <p:sp>
-        <p:nvSpPr>
-          <p:cNvPr id="16" name="Rectangle 15"/>
-          <p:cNvSpPr/>
-          <p:nvPr/>
-        </p:nvSpPr>
-        <p:spPr>
-          <a:xfrm>
-            <a:off x="4251960" y="3566160"/>
-            <a:ext cx="3291840" cy="2103120"/>
-          </a:xfrm>
-          <a:prstGeom prst="rect">
-            <a:avLst/>
-          </a:prstGeom>
-          <a:solidFill>
-            <a:srgbClr val="FFFFFF"/>
-          </a:solidFill>
-          <a:ln w="12700">
-            <a:solidFill>
-              <a:srgbClr val="E2E8F0"/>
-            </a:solidFill>
-          </a:ln>
-        </p:spPr>
-        <p:style>
-          <a:lnRef idx="1">
-            <a:schemeClr val="accent1"/>
-          </a:lnRef>
-          <a:fillRef idx="3">
-            <a:schemeClr val="accent1"/>
-          </a:fillRef>
-          <a:effectRef idx="2">
-            <a:schemeClr val="accent1"/>
-          </a:effectRef>
-          <a:fontRef idx="minor">
-            <a:schemeClr val="lt1"/>
-          </a:fontRef>
-        </p:style>
-        <p:txBody>
-          <a:bodyPr rtlCol="0" anchor="ctr"/>
-          <a:lstStyle/>
-          <a:p>
-            <a:pPr algn="ctr"/>
-          </a:p>
-        </p:txBody>
-      </p:sp>
-      <p:sp>
-        <p:nvSpPr>
-          <p:cNvPr id="17" name="TextBox 16"/>
-          <p:cNvSpPr txBox="1"/>
-          <p:nvPr/>
-        </p:nvSpPr>
-        <p:spPr>
-          <a:xfrm>
-            <a:off x="4434840" y="3703320"/>
-            <a:ext cx="2926080" cy="365760"/>
-          </a:xfrm>
-          <a:prstGeom prst="rect">
-            <a:avLst/>
-          </a:prstGeom>
-          <a:noFill/>
-        </p:spPr>
-        <p:txBody>
-          <a:bodyPr wrap="square">
-            <a:spAutoFit/>
-          </a:bodyPr>
-          <a:lstStyle/>
-          <a:p>
-            <a:r>
-              <a:rPr sz="1400" b="1" i="0">
-                <a:solidFill>
-                  <a:srgbClr val="2563EB"/>
-                </a:solidFill>
-                <a:latin typeface="Times New Roman"/>
-                <a:ea typeface="宋体"/>
-              </a:rPr>
-              <a:t>/brooks-health</a:t>
-            </a:r>
-          </a:p>
-        </p:txBody>
-      </p:sp>
-      <p:sp>
-        <p:nvSpPr>
-          <p:cNvPr id="18" name="TextBox 17"/>
-          <p:cNvSpPr txBox="1"/>
-          <p:nvPr/>
-        </p:nvSpPr>
-        <p:spPr>
-          <a:xfrm>
-            <a:off x="4434840" y="4114800"/>
-            <a:ext cx="2926080" cy="1371600"/>
-          </a:xfrm>
-          <a:prstGeom prst="rect">
-            <a:avLst/>
-          </a:prstGeom>
-          <a:noFill/>
-        </p:spPr>
-        <p:txBody>
-          <a:bodyPr wrap="square">
-            <a:spAutoFit/>
-          </a:bodyPr>
-          <a:lstStyle/>
-          <a:p>
-            <a:r>
-              <a:rPr sz="1000" b="0" i="0">
-                <a:solidFill>
-                  <a:srgbClr val="475569"/>
-                </a:solidFill>
-                <a:latin typeface="Times New Roman"/>
-                <a:ea typeface="宋体"/>
-              </a:rPr>
-              <a:t>代码库健康仪表盘
-四维综合评分
-PR/架构/技术债/测试</a:t>
-            </a:r>
-          </a:p>
-        </p:txBody>
-      </p:sp>
-      <p:sp>
-        <p:nvSpPr>
-          <p:cNvPr id="19" name="Rectangle 18"/>
-          <p:cNvSpPr/>
-          <p:nvPr/>
-        </p:nvSpPr>
-        <p:spPr>
-          <a:xfrm>
-            <a:off x="7772400" y="3566160"/>
-            <a:ext cx="3291840" cy="2103120"/>
-          </a:xfrm>
-          <a:prstGeom prst="rect">
-            <a:avLst/>
-          </a:prstGeom>
-          <a:solidFill>
-            <a:srgbClr val="FFFFFF"/>
-          </a:solidFill>
-          <a:ln w="12700">
-            <a:solidFill>
-              <a:srgbClr val="E2E8F0"/>
-            </a:solidFill>
-          </a:ln>
-        </p:spPr>
-        <p:style>
-          <a:lnRef idx="1">
-            <a:schemeClr val="accent1"/>
-          </a:lnRef>
-          <a:fillRef idx="3">
-            <a:schemeClr val="accent1"/>
-          </a:fillRef>
-          <a:effectRef idx="2">
-            <a:schemeClr val="accent1"/>
-          </a:effectRef>
-          <a:fontRef idx="minor">
-            <a:schemeClr val="lt1"/>
-          </a:fontRef>
-        </p:style>
-        <p:txBody>
-          <a:bodyPr rtlCol="0" anchor="ctr"/>
-          <a:lstStyle/>
-          <a:p>
-            <a:pPr algn="ctr"/>
-          </a:p>
-        </p:txBody>
-      </p:sp>
-      <p:sp>
-        <p:nvSpPr>
-          <p:cNvPr id="20" name="TextBox 19"/>
-          <p:cNvSpPr txBox="1"/>
-          <p:nvPr/>
-        </p:nvSpPr>
-        <p:spPr>
-          <a:xfrm>
-            <a:off x="7955280" y="3703320"/>
-            <a:ext cx="2926080" cy="365760"/>
-          </a:xfrm>
-          <a:prstGeom prst="rect">
-            <a:avLst/>
-          </a:prstGeom>
-          <a:noFill/>
-        </p:spPr>
-        <p:txBody>
-          <a:bodyPr wrap="square">
-            <a:spAutoFit/>
-          </a:bodyPr>
-          <a:lstStyle/>
-          <a:p>
-            <a:r>
-              <a:rPr sz="1400" b="1" i="0">
-                <a:solidFill>
-                  <a:srgbClr val="2563EB"/>
-                </a:solidFill>
-                <a:latin typeface="Times New Roman"/>
-                <a:ea typeface="宋体"/>
-              </a:rPr>
-              <a:t>/brooks-sweep</a:t>
-            </a:r>
-          </a:p>
-        </p:txBody>
-      </p:sp>
-      <p:sp>
-        <p:nvSpPr>
-          <p:cNvPr id="21" name="TextBox 20"/>
-          <p:cNvSpPr txBox="1"/>
-          <p:nvPr/>
-        </p:nvSpPr>
-        <p:spPr>
-          <a:xfrm>
-            <a:off x="7955280" y="4114800"/>
-            <a:ext cx="2926080" cy="1371600"/>
-          </a:xfrm>
-          <a:prstGeom prst="rect">
-            <a:avLst/>
-          </a:prstGeom>
-          <a:noFill/>
-        </p:spPr>
-        <p:txBody>
-          <a:bodyPr wrap="square">
-            <a:spAutoFit/>
-          </a:bodyPr>
-          <a:lstStyle/>
-          <a:p>
-            <a:r>
-              <a:rPr sz="1000" b="0" i="0">
-                <a:solidFill>
-                  <a:srgbClr val="475569"/>
-                </a:solidFill>
-                <a:latin typeface="Times New Roman"/>
-                <a:ea typeface="宋体"/>
-              </a:rPr>
-              <a:t>全库清扫 + 自动修复
-安全变更自动应用
-风险变更确认后执行</a:t>
+              <a:rPr sz="900" b="1">
+                <a:solidFill>
+                  <a:srgbClr val="555555"/>
+                </a:solidFill>
+                <a:latin typeface="Times New Roman"/>
+              </a:rPr>
+              <a:t>🆕 correction 类型收割（ADR-012/013）：</a:t>
+            </a:r>
+            <a:r>
+              <a:rPr sz="900">
+                <a:solidFill>
+                  <a:srgbClr val="555555"/>
+                </a:solidFill>
+                <a:latin typeface="Times New Roman"/>
+              </a:rPr>
+              <a:t>SessionStart 按 correction 类型分类型收割：compliance/未知→自动清除；l3-model-missing/l2-model-missing→持续提示至模型配齐；l2-missing→持久化记录等主 agent 补 L2 段。</a:t>
             </a:r>
           </a:p>
         </p:txBody>
@@ -6922,21 +6500,66 @@
                 <a:latin typeface="Times New Roman"/>
                 <a:ea typeface="宋体"/>
               </a:rPr>
-              <a:t>典型工作流：新功能开发 10 步</a:t>
-            </a:r>
-          </a:p>
-        </p:txBody>
-      </p:sp>
-      <p:sp>
-        <p:nvSpPr>
-          <p:cNvPr id="4" name="TextBox 3"/>
+              <a:t>brooks-lint 代码审查插件</a:t>
+            </a:r>
+          </a:p>
+        </p:txBody>
+      </p:sp>
+      <p:sp>
+        <p:nvSpPr>
+          <p:cNvPr id="4" name="Rectangle 3"/>
+          <p:cNvSpPr/>
+          <p:nvPr/>
+        </p:nvSpPr>
+        <p:spPr>
+          <a:xfrm>
+            <a:off x="731520" y="1234440"/>
+            <a:ext cx="3291840" cy="2103120"/>
+          </a:xfrm>
+          <a:prstGeom prst="rect">
+            <a:avLst/>
+          </a:prstGeom>
+          <a:solidFill>
+            <a:srgbClr val="FFFFFF"/>
+          </a:solidFill>
+          <a:ln w="12700">
+            <a:solidFill>
+              <a:srgbClr val="E2E8F0"/>
+            </a:solidFill>
+          </a:ln>
+        </p:spPr>
+        <p:style>
+          <a:lnRef idx="1">
+            <a:schemeClr val="accent1"/>
+          </a:lnRef>
+          <a:fillRef idx="3">
+            <a:schemeClr val="accent1"/>
+          </a:fillRef>
+          <a:effectRef idx="2">
+            <a:schemeClr val="accent1"/>
+          </a:effectRef>
+          <a:fontRef idx="minor">
+            <a:schemeClr val="lt1"/>
+          </a:fontRef>
+        </p:style>
+        <p:txBody>
+          <a:bodyPr rtlCol="0" anchor="ctr"/>
+          <a:lstStyle/>
+          <a:p>
+            <a:pPr algn="ctr"/>
+          </a:p>
+        </p:txBody>
+      </p:sp>
+      <p:sp>
+        <p:nvSpPr>
+          <p:cNvPr id="5" name="TextBox 4"/>
           <p:cNvSpPr txBox="1"/>
           <p:nvPr/>
         </p:nvSpPr>
         <p:spPr>
           <a:xfrm>
-            <a:off x="731520" y="1280160"/>
-            <a:ext cx="10698480" cy="4754880"/>
+            <a:off x="914400" y="1371600"/>
+            <a:ext cx="2926080" cy="365760"/>
           </a:xfrm>
           <a:prstGeom prst="rect">
             <a:avLst/>
@@ -6950,235 +6573,636 @@
           <a:lstStyle/>
           <a:p>
             <a:r>
-              <a:rPr sz="1300" b="0" i="0">
-                <a:solidFill>
-                  <a:srgbClr val="475569"/>
-                </a:solidFill>
-                <a:latin typeface="Times New Roman"/>
-                <a:ea typeface="宋体"/>
-              </a:rPr>
-              <a:t>步骤 0：/flow start（仅首次，初始化 .flow-active）</a:t>
-            </a:r>
-          </a:p>
-          <a:p>
-            <a:pPr>
-              <a:spcBef>
-                <a:spcPts val="600"/>
-              </a:spcBef>
-            </a:pPr>
-            <a:r>
-              <a:rPr sz="1300" b="0" i="0">
-                <a:solidFill>
-                  <a:srgbClr val="475569"/>
-                </a:solidFill>
-                <a:latin typeface="Times New Roman"/>
-                <a:ea typeface="宋体"/>
-              </a:rPr>
-              <a:t>步骤 1：/flow-go 我想加一个通知中心 → AI 路由到阶段 0，生成 change-id + CHANGE.md</a:t>
-            </a:r>
-          </a:p>
-          <a:p>
-            <a:pPr>
-              <a:spcBef>
-                <a:spcPts val="600"/>
-              </a:spcBef>
-            </a:pPr>
-            <a:r>
-              <a:rPr sz="1300" b="0" i="0">
-                <a:solidFill>
-                  <a:srgbClr val="475569"/>
-                </a:solidFill>
-                <a:latin typeface="Times New Roman"/>
-                <a:ea typeface="宋体"/>
-              </a:rPr>
-              <a:t>步骤 2：/flow-go 写需求 → 阶段 1，REQUIREMENT.md（Given/When/Then AC）</a:t>
-            </a:r>
-          </a:p>
-          <a:p>
-            <a:pPr>
-              <a:spcBef>
-                <a:spcPts val="600"/>
-              </a:spcBef>
-            </a:pPr>
-            <a:r>
-              <a:rPr sz="1300" b="0" i="0">
-                <a:solidFill>
-                  <a:srgbClr val="475569"/>
-                </a:solidFill>
-                <a:latin typeface="Times New Roman"/>
-                <a:ea typeface="宋体"/>
-              </a:rPr>
-              <a:t>步骤 3：/flow-go 做技术设计 → 阶段 2，技术栈预选 + 既有架构对齐 + ADR</a:t>
-            </a:r>
-          </a:p>
-          <a:p>
-            <a:pPr>
-              <a:spcBef>
-                <a:spcPts val="600"/>
-              </a:spcBef>
-            </a:pPr>
-            <a:r>
-              <a:rPr sz="1300" b="0" i="0">
-                <a:solidFill>
-                  <a:srgbClr val="475569"/>
-                </a:solidFill>
-                <a:latin typeface="Times New Roman"/>
-                <a:ea typeface="宋体"/>
-              </a:rPr>
-              <a:t>步骤 4：/flow-go 确定 UI 设计 → 阶段 2a（前端项目），Design Tokens + 组件规约</a:t>
-            </a:r>
-          </a:p>
-          <a:p>
-            <a:pPr>
-              <a:spcBef>
-                <a:spcPts val="600"/>
-              </a:spcBef>
-            </a:pPr>
-            <a:r>
-              <a:rPr sz="1300" b="0" i="0">
-                <a:solidFill>
-                  <a:srgbClr val="475569"/>
-                </a:solidFill>
-                <a:latin typeface="Times New Roman"/>
-                <a:ea typeface="宋体"/>
-              </a:rPr>
-              <a:t>步骤 5：/flow-go 拆任务 → 阶段 3，TASK.md（T1, T2, T3... + 波次划分）</a:t>
-            </a:r>
-          </a:p>
-          <a:p>
-            <a:pPr>
-              <a:spcBef>
-                <a:spcPts val="600"/>
-              </a:spcBef>
-            </a:pPr>
-            <a:r>
-              <a:rPr sz="1300" b="0" i="0">
-                <a:solidFill>
-                  <a:srgbClr val="475569"/>
-                </a:solidFill>
-                <a:latin typeface="Times New Roman"/>
-                <a:ea typeface="宋体"/>
-              </a:rPr>
-              <a:t>步骤 6：/flow-go 执行 T1 → 阶段 4，TDD 驱动开发 → T1-SUMMARY.md</a:t>
-            </a:r>
-          </a:p>
-          <a:p>
-            <a:pPr>
-              <a:spcBef>
-                <a:spcPts val="600"/>
-              </a:spcBef>
-            </a:pPr>
-            <a:r>
-              <a:rPr sz="1300" b="0" i="0">
-                <a:solidFill>
-                  <a:srgbClr val="475569"/>
-                </a:solidFill>
-                <a:latin typeface="Times New Roman"/>
-                <a:ea typeface="宋体"/>
-              </a:rPr>
-              <a:t>步骤 7：/flow-go 开始测试 → 阶段 5，五轮测试金字塔 → TEST.md</a:t>
-            </a:r>
-          </a:p>
-          <a:p>
-            <a:pPr>
-              <a:spcBef>
-                <a:spcPts val="600"/>
-              </a:spcBef>
-            </a:pPr>
-            <a:r>
-              <a:rPr sz="1300" b="0" i="0">
-                <a:solidFill>
-                  <a:srgbClr val="475569"/>
-                </a:solidFill>
-                <a:latin typeface="Times New Roman"/>
-                <a:ea typeface="宋体"/>
-              </a:rPr>
-              <a:t>步骤 8：/flow-go 审查代码 → 阶段 6，三轮审查（spec + 代码质量 + UI）→ REVIEW.md</a:t>
-            </a:r>
-          </a:p>
-          <a:p>
-            <a:pPr>
-              <a:spcBef>
-                <a:spcPts val="600"/>
-              </a:spcBef>
-            </a:pPr>
-            <a:r>
-              <a:rPr sz="1300" b="0" i="0">
-                <a:solidFill>
-                  <a:srgbClr val="475569"/>
-                </a:solidFill>
-                <a:latin typeface="Times New Roman"/>
-                <a:ea typeface="宋体"/>
-              </a:rPr>
-              <a:t>步骤 9：/flow-go 集成上线 → 阶段 7，自动化验证 + UAT + 归档</a:t>
-            </a:r>
-          </a:p>
-          <a:p>
-            <a:pPr>
-              <a:spcBef>
-                <a:spcPts val="600"/>
-              </a:spcBef>
-            </a:pPr>
-            <a:r>
-              <a:rPr sz="1300" b="0" i="0">
-                <a:solidFill>
-                  <a:srgbClr val="475569"/>
-                </a:solidFill>
-                <a:latin typeface="Times New Roman"/>
-                <a:ea typeface="宋体"/>
-              </a:rPr>
-              <a:t>步骤 10：/flow stop → /flow-go 同步架构（A-evolve 沉淀本次架构变更）</a:t>
-            </a:r>
-          </a:p>
-          <a:p>
-            <a:pPr>
-              <a:spcBef>
-                <a:spcPts val="600"/>
-              </a:spcBef>
-            </a:pPr>
-            <a:r>
-              <a:rPr sz="800" b="0" i="0">
-                <a:solidFill>
-                  <a:srgbClr val="475569"/>
-                </a:solidFill>
-                <a:latin typeface="Times New Roman"/>
-                <a:ea typeface="宋体"/>
-              </a:rPr>
-              <a:t/>
-            </a:r>
-          </a:p>
-          <a:p>
-            <a:pPr>
-              <a:spcBef>
-                <a:spcPts val="600"/>
-              </a:spcBef>
-            </a:pPr>
-            <a:r>
-              <a:rPr sz="1200" b="1" i="0">
-                <a:solidFill>
-                  <a:srgbClr val="1E293B"/>
-                </a:solidFill>
-                <a:latin typeface="Times New Roman"/>
-                <a:ea typeface="宋体"/>
-              </a:rPr>
-              <a:t>提示：阶段 0→1→2→2a→3 可以在同一轮对话里连续做——每完成一个阶段 AI 会主动提示下一步，只需回复“继续”。</a:t>
-            </a:r>
-          </a:p>
-          <a:p>
-            <a:pPr>
-              <a:spcBef>
-                <a:spcPts val="600"/>
-              </a:spcBef>
-            </a:pPr>
-            <a:r>
-              <a:rPr sz="1200" b="1" i="0">
-                <a:solidFill>
-                  <a:srgbClr val="1E293B"/>
-                </a:solidFill>
-                <a:latin typeface="Times New Roman"/>
-                <a:ea typeface="宋体"/>
-              </a:rPr>
-              <a:t>小改动（&lt; 50 行）可走压缩流程：AI 判断后可跳过阶段 1/2/3，直接进入阶段 4。</a:t>
+              <a:rPr sz="1400" b="1" i="0">
+                <a:solidFill>
+                  <a:srgbClr val="2563EB"/>
+                </a:solidFill>
+                <a:latin typeface="Times New Roman"/>
+                <a:ea typeface="宋体"/>
+              </a:rPr>
+              <a:t>/brooks-review</a:t>
+            </a:r>
+          </a:p>
+        </p:txBody>
+      </p:sp>
+      <p:sp>
+        <p:nvSpPr>
+          <p:cNvPr id="6" name="TextBox 5"/>
+          <p:cNvSpPr txBox="1"/>
+          <p:nvPr/>
+        </p:nvSpPr>
+        <p:spPr>
+          <a:xfrm>
+            <a:off x="914400" y="1783080"/>
+            <a:ext cx="2926080" cy="1371600"/>
+          </a:xfrm>
+          <a:prstGeom prst="rect">
+            <a:avLst/>
+          </a:prstGeom>
+          <a:noFill/>
+        </p:spPr>
+        <p:txBody>
+          <a:bodyPr wrap="square">
+            <a:spAutoFit/>
+          </a:bodyPr>
+          <a:lstStyle/>
+          <a:p>
+            <a:r>
+              <a:rPr sz="1000" b="0" i="0">
+                <a:solidFill>
+                  <a:srgbClr val="475569"/>
+                </a:solidFill>
+                <a:latin typeface="Times New Roman"/>
+                <a:ea typeface="宋体"/>
+              </a:rPr>
+              <a:t>PR 代码审查
+发现衰退风险和设计坏味
+Symptom→Source→Consequence→Remedy</a:t>
+            </a:r>
+          </a:p>
+        </p:txBody>
+      </p:sp>
+      <p:sp>
+        <p:nvSpPr>
+          <p:cNvPr id="7" name="Rectangle 6"/>
+          <p:cNvSpPr/>
+          <p:nvPr/>
+        </p:nvSpPr>
+        <p:spPr>
+          <a:xfrm>
+            <a:off x="4251960" y="1234440"/>
+            <a:ext cx="3291840" cy="2103120"/>
+          </a:xfrm>
+          <a:prstGeom prst="rect">
+            <a:avLst/>
+          </a:prstGeom>
+          <a:solidFill>
+            <a:srgbClr val="FFFFFF"/>
+          </a:solidFill>
+          <a:ln w="12700">
+            <a:solidFill>
+              <a:srgbClr val="E2E8F0"/>
+            </a:solidFill>
+          </a:ln>
+        </p:spPr>
+        <p:style>
+          <a:lnRef idx="1">
+            <a:schemeClr val="accent1"/>
+          </a:lnRef>
+          <a:fillRef idx="3">
+            <a:schemeClr val="accent1"/>
+          </a:fillRef>
+          <a:effectRef idx="2">
+            <a:schemeClr val="accent1"/>
+          </a:effectRef>
+          <a:fontRef idx="minor">
+            <a:schemeClr val="lt1"/>
+          </a:fontRef>
+        </p:style>
+        <p:txBody>
+          <a:bodyPr rtlCol="0" anchor="ctr"/>
+          <a:lstStyle/>
+          <a:p>
+            <a:pPr algn="ctr"/>
+          </a:p>
+        </p:txBody>
+      </p:sp>
+      <p:sp>
+        <p:nvSpPr>
+          <p:cNvPr id="8" name="TextBox 7"/>
+          <p:cNvSpPr txBox="1"/>
+          <p:nvPr/>
+        </p:nvSpPr>
+        <p:spPr>
+          <a:xfrm>
+            <a:off x="4434840" y="1371600"/>
+            <a:ext cx="2926080" cy="365760"/>
+          </a:xfrm>
+          <a:prstGeom prst="rect">
+            <a:avLst/>
+          </a:prstGeom>
+          <a:noFill/>
+        </p:spPr>
+        <p:txBody>
+          <a:bodyPr wrap="square">
+            <a:spAutoFit/>
+          </a:bodyPr>
+          <a:lstStyle/>
+          <a:p>
+            <a:r>
+              <a:rPr sz="1400" b="1" i="0">
+                <a:solidFill>
+                  <a:srgbClr val="2563EB"/>
+                </a:solidFill>
+                <a:latin typeface="Times New Roman"/>
+                <a:ea typeface="宋体"/>
+              </a:rPr>
+              <a:t>/brooks-audit</a:t>
+            </a:r>
+          </a:p>
+        </p:txBody>
+      </p:sp>
+      <p:sp>
+        <p:nvSpPr>
+          <p:cNvPr id="9" name="TextBox 8"/>
+          <p:cNvSpPr txBox="1"/>
+          <p:nvPr/>
+        </p:nvSpPr>
+        <p:spPr>
+          <a:xfrm>
+            <a:off x="4434840" y="1783080"/>
+            <a:ext cx="2926080" cy="1371600"/>
+          </a:xfrm>
+          <a:prstGeom prst="rect">
+            <a:avLst/>
+          </a:prstGeom>
+          <a:noFill/>
+        </p:spPr>
+        <p:txBody>
+          <a:bodyPr wrap="square">
+            <a:spAutoFit/>
+          </a:bodyPr>
+          <a:lstStyle/>
+          <a:p>
+            <a:r>
+              <a:rPr sz="1000" b="0" i="0">
+                <a:solidFill>
+                  <a:srgbClr val="475569"/>
+                </a:solidFill>
+                <a:latin typeface="Times New Roman"/>
+                <a:ea typeface="宋体"/>
+              </a:rPr>
+              <a:t>架构审计
+模块依赖图 + 分层完整性
++ 循环依赖检测</a:t>
+            </a:r>
+          </a:p>
+        </p:txBody>
+      </p:sp>
+      <p:sp>
+        <p:nvSpPr>
+          <p:cNvPr id="10" name="Rectangle 9"/>
+          <p:cNvSpPr/>
+          <p:nvPr/>
+        </p:nvSpPr>
+        <p:spPr>
+          <a:xfrm>
+            <a:off x="7772400" y="1234440"/>
+            <a:ext cx="3291840" cy="2103120"/>
+          </a:xfrm>
+          <a:prstGeom prst="rect">
+            <a:avLst/>
+          </a:prstGeom>
+          <a:solidFill>
+            <a:srgbClr val="FFFFFF"/>
+          </a:solidFill>
+          <a:ln w="12700">
+            <a:solidFill>
+              <a:srgbClr val="E2E8F0"/>
+            </a:solidFill>
+          </a:ln>
+        </p:spPr>
+        <p:style>
+          <a:lnRef idx="1">
+            <a:schemeClr val="accent1"/>
+          </a:lnRef>
+          <a:fillRef idx="3">
+            <a:schemeClr val="accent1"/>
+          </a:fillRef>
+          <a:effectRef idx="2">
+            <a:schemeClr val="accent1"/>
+          </a:effectRef>
+          <a:fontRef idx="minor">
+            <a:schemeClr val="lt1"/>
+          </a:fontRef>
+        </p:style>
+        <p:txBody>
+          <a:bodyPr rtlCol="0" anchor="ctr"/>
+          <a:lstStyle/>
+          <a:p>
+            <a:pPr algn="ctr"/>
+          </a:p>
+        </p:txBody>
+      </p:sp>
+      <p:sp>
+        <p:nvSpPr>
+          <p:cNvPr id="11" name="TextBox 10"/>
+          <p:cNvSpPr txBox="1"/>
+          <p:nvPr/>
+        </p:nvSpPr>
+        <p:spPr>
+          <a:xfrm>
+            <a:off x="7955280" y="1371600"/>
+            <a:ext cx="2926080" cy="365760"/>
+          </a:xfrm>
+          <a:prstGeom prst="rect">
+            <a:avLst/>
+          </a:prstGeom>
+          <a:noFill/>
+        </p:spPr>
+        <p:txBody>
+          <a:bodyPr wrap="square">
+            <a:spAutoFit/>
+          </a:bodyPr>
+          <a:lstStyle/>
+          <a:p>
+            <a:r>
+              <a:rPr sz="1400" b="1" i="0">
+                <a:solidFill>
+                  <a:srgbClr val="2563EB"/>
+                </a:solidFill>
+                <a:latin typeface="Times New Roman"/>
+                <a:ea typeface="宋体"/>
+              </a:rPr>
+              <a:t>/brooks-debt</a:t>
+            </a:r>
+          </a:p>
+        </p:txBody>
+      </p:sp>
+      <p:sp>
+        <p:nvSpPr>
+          <p:cNvPr id="12" name="TextBox 11"/>
+          <p:cNvSpPr txBox="1"/>
+          <p:nvPr/>
+        </p:nvSpPr>
+        <p:spPr>
+          <a:xfrm>
+            <a:off x="7955280" y="1783080"/>
+            <a:ext cx="2926080" cy="1371600"/>
+          </a:xfrm>
+          <a:prstGeom prst="rect">
+            <a:avLst/>
+          </a:prstGeom>
+          <a:noFill/>
+        </p:spPr>
+        <p:txBody>
+          <a:bodyPr wrap="square">
+            <a:spAutoFit/>
+          </a:bodyPr>
+          <a:lstStyle/>
+          <a:p>
+            <a:r>
+              <a:rPr sz="1000" b="0" i="0">
+                <a:solidFill>
+                  <a:srgbClr val="475569"/>
+                </a:solidFill>
+                <a:latin typeface="Times New Roman"/>
+                <a:ea typeface="宋体"/>
+              </a:rPr>
+              <a:t>技术债评估
+分类 + 优先级排序
+构建重构路线图</a:t>
+            </a:r>
+          </a:p>
+        </p:txBody>
+      </p:sp>
+      <p:sp>
+        <p:nvSpPr>
+          <p:cNvPr id="13" name="Rectangle 12"/>
+          <p:cNvSpPr/>
+          <p:nvPr/>
+        </p:nvSpPr>
+        <p:spPr>
+          <a:xfrm>
+            <a:off x="731520" y="3566160"/>
+            <a:ext cx="3291840" cy="2103120"/>
+          </a:xfrm>
+          <a:prstGeom prst="rect">
+            <a:avLst/>
+          </a:prstGeom>
+          <a:solidFill>
+            <a:srgbClr val="FFFFFF"/>
+          </a:solidFill>
+          <a:ln w="12700">
+            <a:solidFill>
+              <a:srgbClr val="E2E8F0"/>
+            </a:solidFill>
+          </a:ln>
+        </p:spPr>
+        <p:style>
+          <a:lnRef idx="1">
+            <a:schemeClr val="accent1"/>
+          </a:lnRef>
+          <a:fillRef idx="3">
+            <a:schemeClr val="accent1"/>
+          </a:fillRef>
+          <a:effectRef idx="2">
+            <a:schemeClr val="accent1"/>
+          </a:effectRef>
+          <a:fontRef idx="minor">
+            <a:schemeClr val="lt1"/>
+          </a:fontRef>
+        </p:style>
+        <p:txBody>
+          <a:bodyPr rtlCol="0" anchor="ctr"/>
+          <a:lstStyle/>
+          <a:p>
+            <a:pPr algn="ctr"/>
+          </a:p>
+        </p:txBody>
+      </p:sp>
+      <p:sp>
+        <p:nvSpPr>
+          <p:cNvPr id="14" name="TextBox 13"/>
+          <p:cNvSpPr txBox="1"/>
+          <p:nvPr/>
+        </p:nvSpPr>
+        <p:spPr>
+          <a:xfrm>
+            <a:off x="914400" y="3703320"/>
+            <a:ext cx="2926080" cy="365760"/>
+          </a:xfrm>
+          <a:prstGeom prst="rect">
+            <a:avLst/>
+          </a:prstGeom>
+          <a:noFill/>
+        </p:spPr>
+        <p:txBody>
+          <a:bodyPr wrap="square">
+            <a:spAutoFit/>
+          </a:bodyPr>
+          <a:lstStyle/>
+          <a:p>
+            <a:r>
+              <a:rPr sz="1400" b="1" i="0">
+                <a:solidFill>
+                  <a:srgbClr val="2563EB"/>
+                </a:solidFill>
+                <a:latin typeface="Times New Roman"/>
+                <a:ea typeface="宋体"/>
+              </a:rPr>
+              <a:t>/brooks-test</a:t>
+            </a:r>
+          </a:p>
+        </p:txBody>
+      </p:sp>
+      <p:sp>
+        <p:nvSpPr>
+          <p:cNvPr id="15" name="TextBox 14"/>
+          <p:cNvSpPr txBox="1"/>
+          <p:nvPr/>
+        </p:nvSpPr>
+        <p:spPr>
+          <a:xfrm>
+            <a:off x="914400" y="4114800"/>
+            <a:ext cx="2926080" cy="1371600"/>
+          </a:xfrm>
+          <a:prstGeom prst="rect">
+            <a:avLst/>
+          </a:prstGeom>
+          <a:noFill/>
+        </p:spPr>
+        <p:txBody>
+          <a:bodyPr wrap="square">
+            <a:spAutoFit/>
+          </a:bodyPr>
+          <a:lstStyle/>
+          <a:p>
+            <a:r>
+              <a:rPr sz="1000" b="0" i="0">
+                <a:solidFill>
+                  <a:srgbClr val="475569"/>
+                </a:solidFill>
+                <a:latin typeface="Times New Roman"/>
+                <a:ea typeface="宋体"/>
+              </a:rPr>
+              <a:t>测试质量审查
+脆性测试 / mock 滥用
+/ 覆盖率幻觉诊断</a:t>
+            </a:r>
+          </a:p>
+        </p:txBody>
+      </p:sp>
+      <p:sp>
+        <p:nvSpPr>
+          <p:cNvPr id="16" name="Rectangle 15"/>
+          <p:cNvSpPr/>
+          <p:nvPr/>
+        </p:nvSpPr>
+        <p:spPr>
+          <a:xfrm>
+            <a:off x="4251960" y="3566160"/>
+            <a:ext cx="3291840" cy="2103120"/>
+          </a:xfrm>
+          <a:prstGeom prst="rect">
+            <a:avLst/>
+          </a:prstGeom>
+          <a:solidFill>
+            <a:srgbClr val="FFFFFF"/>
+          </a:solidFill>
+          <a:ln w="12700">
+            <a:solidFill>
+              <a:srgbClr val="E2E8F0"/>
+            </a:solidFill>
+          </a:ln>
+        </p:spPr>
+        <p:style>
+          <a:lnRef idx="1">
+            <a:schemeClr val="accent1"/>
+          </a:lnRef>
+          <a:fillRef idx="3">
+            <a:schemeClr val="accent1"/>
+          </a:fillRef>
+          <a:effectRef idx="2">
+            <a:schemeClr val="accent1"/>
+          </a:effectRef>
+          <a:fontRef idx="minor">
+            <a:schemeClr val="lt1"/>
+          </a:fontRef>
+        </p:style>
+        <p:txBody>
+          <a:bodyPr rtlCol="0" anchor="ctr"/>
+          <a:lstStyle/>
+          <a:p>
+            <a:pPr algn="ctr"/>
+          </a:p>
+        </p:txBody>
+      </p:sp>
+      <p:sp>
+        <p:nvSpPr>
+          <p:cNvPr id="17" name="TextBox 16"/>
+          <p:cNvSpPr txBox="1"/>
+          <p:nvPr/>
+        </p:nvSpPr>
+        <p:spPr>
+          <a:xfrm>
+            <a:off x="4434840" y="3703320"/>
+            <a:ext cx="2926080" cy="365760"/>
+          </a:xfrm>
+          <a:prstGeom prst="rect">
+            <a:avLst/>
+          </a:prstGeom>
+          <a:noFill/>
+        </p:spPr>
+        <p:txBody>
+          <a:bodyPr wrap="square">
+            <a:spAutoFit/>
+          </a:bodyPr>
+          <a:lstStyle/>
+          <a:p>
+            <a:r>
+              <a:rPr sz="1400" b="1" i="0">
+                <a:solidFill>
+                  <a:srgbClr val="2563EB"/>
+                </a:solidFill>
+                <a:latin typeface="Times New Roman"/>
+                <a:ea typeface="宋体"/>
+              </a:rPr>
+              <a:t>/brooks-health</a:t>
+            </a:r>
+          </a:p>
+        </p:txBody>
+      </p:sp>
+      <p:sp>
+        <p:nvSpPr>
+          <p:cNvPr id="18" name="TextBox 17"/>
+          <p:cNvSpPr txBox="1"/>
+          <p:nvPr/>
+        </p:nvSpPr>
+        <p:spPr>
+          <a:xfrm>
+            <a:off x="4434840" y="4114800"/>
+            <a:ext cx="2926080" cy="1371600"/>
+          </a:xfrm>
+          <a:prstGeom prst="rect">
+            <a:avLst/>
+          </a:prstGeom>
+          <a:noFill/>
+        </p:spPr>
+        <p:txBody>
+          <a:bodyPr wrap="square">
+            <a:spAutoFit/>
+          </a:bodyPr>
+          <a:lstStyle/>
+          <a:p>
+            <a:r>
+              <a:rPr sz="1000" b="0" i="0">
+                <a:solidFill>
+                  <a:srgbClr val="475569"/>
+                </a:solidFill>
+                <a:latin typeface="Times New Roman"/>
+                <a:ea typeface="宋体"/>
+              </a:rPr>
+              <a:t>代码库健康仪表盘
+四维综合评分
+PR/架构/技术债/测试</a:t>
+            </a:r>
+          </a:p>
+        </p:txBody>
+      </p:sp>
+      <p:sp>
+        <p:nvSpPr>
+          <p:cNvPr id="19" name="Rectangle 18"/>
+          <p:cNvSpPr/>
+          <p:nvPr/>
+        </p:nvSpPr>
+        <p:spPr>
+          <a:xfrm>
+            <a:off x="7772400" y="3566160"/>
+            <a:ext cx="3291840" cy="2103120"/>
+          </a:xfrm>
+          <a:prstGeom prst="rect">
+            <a:avLst/>
+          </a:prstGeom>
+          <a:solidFill>
+            <a:srgbClr val="FFFFFF"/>
+          </a:solidFill>
+          <a:ln w="12700">
+            <a:solidFill>
+              <a:srgbClr val="E2E8F0"/>
+            </a:solidFill>
+          </a:ln>
+        </p:spPr>
+        <p:style>
+          <a:lnRef idx="1">
+            <a:schemeClr val="accent1"/>
+          </a:lnRef>
+          <a:fillRef idx="3">
+            <a:schemeClr val="accent1"/>
+          </a:fillRef>
+          <a:effectRef idx="2">
+            <a:schemeClr val="accent1"/>
+          </a:effectRef>
+          <a:fontRef idx="minor">
+            <a:schemeClr val="lt1"/>
+          </a:fontRef>
+        </p:style>
+        <p:txBody>
+          <a:bodyPr rtlCol="0" anchor="ctr"/>
+          <a:lstStyle/>
+          <a:p>
+            <a:pPr algn="ctr"/>
+          </a:p>
+        </p:txBody>
+      </p:sp>
+      <p:sp>
+        <p:nvSpPr>
+          <p:cNvPr id="20" name="TextBox 19"/>
+          <p:cNvSpPr txBox="1"/>
+          <p:nvPr/>
+        </p:nvSpPr>
+        <p:spPr>
+          <a:xfrm>
+            <a:off x="7955280" y="3703320"/>
+            <a:ext cx="2926080" cy="365760"/>
+          </a:xfrm>
+          <a:prstGeom prst="rect">
+            <a:avLst/>
+          </a:prstGeom>
+          <a:noFill/>
+        </p:spPr>
+        <p:txBody>
+          <a:bodyPr wrap="square">
+            <a:spAutoFit/>
+          </a:bodyPr>
+          <a:lstStyle/>
+          <a:p>
+            <a:r>
+              <a:rPr sz="1400" b="1" i="0">
+                <a:solidFill>
+                  <a:srgbClr val="2563EB"/>
+                </a:solidFill>
+                <a:latin typeface="Times New Roman"/>
+                <a:ea typeface="宋体"/>
+              </a:rPr>
+              <a:t>/brooks-sweep</a:t>
+            </a:r>
+          </a:p>
+        </p:txBody>
+      </p:sp>
+      <p:sp>
+        <p:nvSpPr>
+          <p:cNvPr id="21" name="TextBox 20"/>
+          <p:cNvSpPr txBox="1"/>
+          <p:nvPr/>
+        </p:nvSpPr>
+        <p:spPr>
+          <a:xfrm>
+            <a:off x="7955280" y="4114800"/>
+            <a:ext cx="2926080" cy="1371600"/>
+          </a:xfrm>
+          <a:prstGeom prst="rect">
+            <a:avLst/>
+          </a:prstGeom>
+          <a:noFill/>
+        </p:spPr>
+        <p:txBody>
+          <a:bodyPr wrap="square">
+            <a:spAutoFit/>
+          </a:bodyPr>
+          <a:lstStyle/>
+          <a:p>
+            <a:r>
+              <a:rPr sz="1000" b="0" i="0">
+                <a:solidFill>
+                  <a:srgbClr val="475569"/>
+                </a:solidFill>
+                <a:latin typeface="Times New Roman"/>
+                <a:ea typeface="宋体"/>
+              </a:rPr>
+              <a:t>全库清扫 + 自动修复
+安全变更自动应用
+风险变更确认后执行</a:t>
             </a:r>
           </a:p>
         </p:txBody>
@@ -7274,6 +7298,358 @@
                 <a:latin typeface="Times New Roman"/>
                 <a:ea typeface="宋体"/>
               </a:rPr>
+              <a:t>典型工作流：新功能开发 10 步</a:t>
+            </a:r>
+          </a:p>
+        </p:txBody>
+      </p:sp>
+      <p:sp>
+        <p:nvSpPr>
+          <p:cNvPr id="4" name="TextBox 3"/>
+          <p:cNvSpPr txBox="1"/>
+          <p:nvPr/>
+        </p:nvSpPr>
+        <p:spPr>
+          <a:xfrm>
+            <a:off x="731520" y="1280160"/>
+            <a:ext cx="10698480" cy="4754880"/>
+          </a:xfrm>
+          <a:prstGeom prst="rect">
+            <a:avLst/>
+          </a:prstGeom>
+          <a:noFill/>
+        </p:spPr>
+        <p:txBody>
+          <a:bodyPr wrap="square">
+            <a:spAutoFit/>
+          </a:bodyPr>
+          <a:lstStyle/>
+          <a:p>
+            <a:r>
+              <a:rPr sz="1300" b="0" i="0">
+                <a:solidFill>
+                  <a:srgbClr val="475569"/>
+                </a:solidFill>
+                <a:latin typeface="Times New Roman"/>
+                <a:ea typeface="宋体"/>
+              </a:rPr>
+              <a:t>步骤 0：/flow start（仅首次，初始化 .flow-active）</a:t>
+            </a:r>
+          </a:p>
+          <a:p>
+            <a:pPr>
+              <a:spcBef>
+                <a:spcPts val="600"/>
+              </a:spcBef>
+            </a:pPr>
+            <a:r>
+              <a:rPr sz="1300" b="0" i="0">
+                <a:solidFill>
+                  <a:srgbClr val="475569"/>
+                </a:solidFill>
+                <a:latin typeface="Times New Roman"/>
+                <a:ea typeface="宋体"/>
+              </a:rPr>
+              <a:t>步骤 1：/flow-go 我想加一个通知中心 → AI 路由到阶段 0，生成 change-id + CHANGE.md</a:t>
+            </a:r>
+          </a:p>
+          <a:p>
+            <a:pPr>
+              <a:spcBef>
+                <a:spcPts val="600"/>
+              </a:spcBef>
+            </a:pPr>
+            <a:r>
+              <a:rPr sz="1300" b="0" i="0">
+                <a:solidFill>
+                  <a:srgbClr val="475569"/>
+                </a:solidFill>
+                <a:latin typeface="Times New Roman"/>
+                <a:ea typeface="宋体"/>
+              </a:rPr>
+              <a:t>步骤 2：/flow-go 写需求 → 阶段 1，REQUIREMENT.md（Given/When/Then AC）</a:t>
+            </a:r>
+          </a:p>
+          <a:p>
+            <a:pPr>
+              <a:spcBef>
+                <a:spcPts val="600"/>
+              </a:spcBef>
+            </a:pPr>
+            <a:r>
+              <a:rPr sz="1300" b="0" i="0">
+                <a:solidFill>
+                  <a:srgbClr val="475569"/>
+                </a:solidFill>
+                <a:latin typeface="Times New Roman"/>
+                <a:ea typeface="宋体"/>
+              </a:rPr>
+              <a:t>步骤 3：/flow-go 做技术设计 → 阶段 2，技术栈预选 + 既有架构对齐 + ADR</a:t>
+            </a:r>
+          </a:p>
+          <a:p>
+            <a:pPr>
+              <a:spcBef>
+                <a:spcPts val="600"/>
+              </a:spcBef>
+            </a:pPr>
+            <a:r>
+              <a:rPr sz="1300" b="0" i="0">
+                <a:solidFill>
+                  <a:srgbClr val="475569"/>
+                </a:solidFill>
+                <a:latin typeface="Times New Roman"/>
+                <a:ea typeface="宋体"/>
+              </a:rPr>
+              <a:t>步骤 4：/flow-go 确定 UI 设计 → 阶段 2a（前端项目），Design Tokens + 组件规约</a:t>
+            </a:r>
+          </a:p>
+          <a:p>
+            <a:pPr>
+              <a:spcBef>
+                <a:spcPts val="600"/>
+              </a:spcBef>
+            </a:pPr>
+            <a:r>
+              <a:rPr sz="1300" b="0" i="0">
+                <a:solidFill>
+                  <a:srgbClr val="475569"/>
+                </a:solidFill>
+                <a:latin typeface="Times New Roman"/>
+                <a:ea typeface="宋体"/>
+              </a:rPr>
+              <a:t>步骤 5：/flow-go 拆任务 → 阶段 3，TASK.md（T1, T2, T3... + 波次划分）</a:t>
+            </a:r>
+          </a:p>
+          <a:p>
+            <a:pPr>
+              <a:spcBef>
+                <a:spcPts val="600"/>
+              </a:spcBef>
+            </a:pPr>
+            <a:r>
+              <a:rPr sz="1300" b="0" i="0">
+                <a:solidFill>
+                  <a:srgbClr val="475569"/>
+                </a:solidFill>
+                <a:latin typeface="Times New Roman"/>
+                <a:ea typeface="宋体"/>
+              </a:rPr>
+              <a:t>步骤 6：/flow-go 执行 T1 → 阶段 4，TDD 驱动开发 → T1-SUMMARY.md</a:t>
+            </a:r>
+          </a:p>
+          <a:p>
+            <a:pPr>
+              <a:spcBef>
+                <a:spcPts val="600"/>
+              </a:spcBef>
+            </a:pPr>
+            <a:r>
+              <a:rPr sz="1300" b="0" i="0">
+                <a:solidFill>
+                  <a:srgbClr val="475569"/>
+                </a:solidFill>
+                <a:latin typeface="Times New Roman"/>
+                <a:ea typeface="宋体"/>
+              </a:rPr>
+              <a:t>步骤 7：/flow-go 开始测试 → 阶段 5，五轮测试金字塔 → TEST.md</a:t>
+            </a:r>
+          </a:p>
+          <a:p>
+            <a:pPr>
+              <a:spcBef>
+                <a:spcPts val="600"/>
+              </a:spcBef>
+            </a:pPr>
+            <a:r>
+              <a:rPr sz="1300" b="0" i="0">
+                <a:solidFill>
+                  <a:srgbClr val="475569"/>
+                </a:solidFill>
+                <a:latin typeface="Times New Roman"/>
+                <a:ea typeface="宋体"/>
+              </a:rPr>
+              <a:t>步骤 8：/flow-go 审查代码 → 阶段 6，三轮审查（spec + 代码质量 + UI）→ REVIEW.md</a:t>
+            </a:r>
+          </a:p>
+          <a:p>
+            <a:pPr>
+              <a:spcBef>
+                <a:spcPts val="600"/>
+              </a:spcBef>
+            </a:pPr>
+            <a:r>
+              <a:rPr sz="1300" b="0" i="0">
+                <a:solidFill>
+                  <a:srgbClr val="475569"/>
+                </a:solidFill>
+                <a:latin typeface="Times New Roman"/>
+                <a:ea typeface="宋体"/>
+              </a:rPr>
+              <a:t>步骤 9：/flow-go 集成上线 → 阶段 7，自动化验证 + UAT + 归档</a:t>
+            </a:r>
+          </a:p>
+          <a:p>
+            <a:pPr>
+              <a:spcBef>
+                <a:spcPts val="600"/>
+              </a:spcBef>
+            </a:pPr>
+            <a:r>
+              <a:rPr sz="1300" b="0" i="0">
+                <a:solidFill>
+                  <a:srgbClr val="475569"/>
+                </a:solidFill>
+                <a:latin typeface="Times New Roman"/>
+                <a:ea typeface="宋体"/>
+              </a:rPr>
+              <a:t>步骤 10：/flow stop → /flow-go 同步架构（A-evolve 沉淀本次架构变更）</a:t>
+            </a:r>
+          </a:p>
+          <a:p>
+            <a:pPr>
+              <a:spcBef>
+                <a:spcPts val="600"/>
+              </a:spcBef>
+            </a:pPr>
+            <a:r>
+              <a:rPr sz="800" b="0" i="0">
+                <a:solidFill>
+                  <a:srgbClr val="475569"/>
+                </a:solidFill>
+                <a:latin typeface="Times New Roman"/>
+                <a:ea typeface="宋体"/>
+              </a:rPr>
+              <a:t/>
+            </a:r>
+          </a:p>
+          <a:p>
+            <a:pPr>
+              <a:spcBef>
+                <a:spcPts val="600"/>
+              </a:spcBef>
+            </a:pPr>
+            <a:r>
+              <a:rPr sz="1200" b="1" i="0">
+                <a:solidFill>
+                  <a:srgbClr val="1E293B"/>
+                </a:solidFill>
+                <a:latin typeface="Times New Roman"/>
+                <a:ea typeface="宋体"/>
+              </a:rPr>
+              <a:t>提示：阶段 0→1→2→2a→3 可以在同一轮对话里连续做——每完成一个阶段 AI 会主动提示下一步，只需回复“继续”。</a:t>
+            </a:r>
+          </a:p>
+          <a:p>
+            <a:pPr>
+              <a:spcBef>
+                <a:spcPts val="600"/>
+              </a:spcBef>
+            </a:pPr>
+            <a:r>
+              <a:rPr sz="1200" b="1" i="0">
+                <a:solidFill>
+                  <a:srgbClr val="1E293B"/>
+                </a:solidFill>
+                <a:latin typeface="Times New Roman"/>
+                <a:ea typeface="宋体"/>
+              </a:rPr>
+              <a:t>小改动（&lt; 50 行）可走压缩流程：AI 判断后可跳过阶段 1/2/3，直接进入阶段 4。</a:t>
+            </a:r>
+          </a:p>
+        </p:txBody>
+      </p:sp>
+    </p:spTree>
+  </p:cSld>
+  <p:clrMapOvr>
+    <a:masterClrMapping/>
+  </p:clrMapOvr>
+</p:sld>
+</file>
+
+<file path=ppt/slides/slide19.xml><?xml version="1.0" encoding="utf-8"?>
+<p:sld xmlns:a="http://schemas.openxmlformats.org/drawingml/2006/main" xmlns:p="http://schemas.openxmlformats.org/presentationml/2006/main" xmlns:r="http://schemas.openxmlformats.org/officeDocument/2006/relationships">
+  <p:cSld>
+    <p:spTree>
+      <p:nvGrpSpPr>
+        <p:cNvPr id="1" name=""/>
+        <p:cNvGrpSpPr/>
+        <p:nvPr/>
+      </p:nvGrpSpPr>
+      <p:grpSpPr/>
+      <p:sp>
+        <p:nvSpPr>
+          <p:cNvPr id="2" name="Rectangle 1"/>
+          <p:cNvSpPr/>
+          <p:nvPr/>
+        </p:nvSpPr>
+        <p:spPr>
+          <a:xfrm>
+            <a:off x="731520" y="320040"/>
+            <a:ext cx="54864" cy="365760"/>
+          </a:xfrm>
+          <a:prstGeom prst="rect">
+            <a:avLst/>
+          </a:prstGeom>
+          <a:solidFill>
+            <a:srgbClr val="2563EB"/>
+          </a:solidFill>
+          <a:ln>
+            <a:noFill/>
+          </a:ln>
+        </p:spPr>
+        <p:style>
+          <a:lnRef idx="1">
+            <a:schemeClr val="accent1"/>
+          </a:lnRef>
+          <a:fillRef idx="3">
+            <a:schemeClr val="accent1"/>
+          </a:fillRef>
+          <a:effectRef idx="2">
+            <a:schemeClr val="accent1"/>
+          </a:effectRef>
+          <a:fontRef idx="minor">
+            <a:schemeClr val="lt1"/>
+          </a:fontRef>
+        </p:style>
+        <p:txBody>
+          <a:bodyPr rtlCol="0" anchor="ctr"/>
+          <a:lstStyle/>
+          <a:p>
+            <a:pPr algn="ctr"/>
+          </a:p>
+        </p:txBody>
+      </p:sp>
+      <p:sp>
+        <p:nvSpPr>
+          <p:cNvPr id="3" name="TextBox 2"/>
+          <p:cNvSpPr txBox="1"/>
+          <p:nvPr/>
+        </p:nvSpPr>
+        <p:spPr>
+          <a:xfrm>
+            <a:off x="914400" y="274320"/>
+            <a:ext cx="10515600" cy="502920"/>
+          </a:xfrm>
+          <a:prstGeom prst="rect">
+            <a:avLst/>
+          </a:prstGeom>
+          <a:noFill/>
+        </p:spPr>
+        <p:txBody>
+          <a:bodyPr wrap="square">
+            <a:spAutoFit/>
+          </a:bodyPr>
+          <a:lstStyle/>
+          <a:p>
+            <a:r>
+              <a:rPr sz="2400" b="1" i="0">
+                <a:solidFill>
+                  <a:srgbClr val="1E293B"/>
+                </a:solidFill>
+                <a:latin typeface="Times New Roman"/>
+                <a:ea typeface="宋体"/>
+              </a:rPr>
               <a:t>文件结构 + Token 预算参考</a:t>
             </a:r>
           </a:p>
@@ -9244,6 +9620,49 @@
                 <a:ea typeface="宋体"/>
               </a:rPr>
               <a:t>审查 → 阶段 6 | 集成 → 阶段 7 | 体检 → M-health | 扫描 → I-intel | 架构 → A-architect</a:t>
+            </a:r>
+          </a:p>
+        </p:txBody>
+      </p:sp>
+      <p:sp>
+        <p:nvSpPr>
+          <p:cNvPr id="5" name="TextBox 4"/>
+          <p:cNvSpPr txBox="1"/>
+          <p:nvPr/>
+        </p:nvSpPr>
+        <p:spPr>
+          <a:xfrm>
+            <a:off x="914400" y="5394960"/>
+            <a:ext cx="7315200" cy="365760"/>
+          </a:xfrm>
+          <a:prstGeom prst="rect">
+            <a:avLst/>
+          </a:prstGeom>
+          <a:noFill/>
+        </p:spPr>
+        <p:txBody>
+          <a:bodyPr wrap="square">
+            <a:spAutoFit/>
+          </a:bodyPr>
+          <a:lstStyle/>
+          <a:p>
+            <a:r>
+              <a:rPr sz="900" b="1">
+                <a:solidFill>
+                  <a:srgbClr val="555555"/>
+                </a:solidFill>
+                <a:latin typeface="Times New Roman"/>
+              </a:rPr>
+              <a:t>🆕 2026-07-24 新增：</a:t>
+            </a:r>
+            <a:r>
+              <a:rPr sz="900">
+                <a:solidFill>
+                  <a:srgbClr val="555555"/>
+                </a:solidFill>
+                <a:latin typeface="Times New Roman"/>
+              </a:rPr>
+              <a:t> | /flow model [l2=&lt;模型&gt;] [l3=&lt;模型&gt;] — 查询/设置 L2/L3 审查模型</a:t>
             </a:r>
           </a:p>
         </p:txBody>

</xml_diff>